<commit_message>
fix: Update VP readout with Kevin's DPM method and simplified MFG/ENG view
Changes:
- Use Kevin's DPM calculation: (Unique MSNs / Total FID UIN) × 1M
  - HMB1: 500 / 1,881,631 × 1M = 265.73 DPM
  - QMON: 292 / 1,527,576 × 1M = 191.15 DPM

- Replace confusing 1st pass vs final pass yield comparison with
  simple MFG vs ENG view table showing:
  - MFG View: Yield % (what manufacturing sees)
  - ENG View: cDPM (what engineering sees for customer risk)

- Key message: MFG sees 97.1% yield, ENG sees 456.9 cDPM total risk
  → After recovery: 157.9 cDPM customer-facing (65% recovery)

Slides:
1. Title
2. Executive Summary
3. MFG vs ENG View (simplified bridge)
4. DPM Calculation Methodology (Kevin's method)
5. Top FAILCRAWLERs by DPM
6. Recovery Type Assignments
7. Recovery Summary Table
8. DPM Waterfall Chart
9. Appendix: Data Sources
</commit_message>
<xml_diff>
--- a/Y6CP_cDPM_Recovery_VP_Readout_SOCAMM2_7500MT.pptx
+++ b/Y6CP_cDPM_Recovery_VP_Readout_SOCAMM2_7500MT.pptx
@@ -14,7 +14,6 @@
     <p:sldId id="262" r:id="rId13"/>
     <p:sldId id="263" r:id="rId14"/>
     <p:sldId id="264" r:id="rId15"/>
-    <p:sldId id="265" r:id="rId16"/>
   </p:sldIdLst>
   <p:sldSz cx="12191695" cy="6858000" type="screen4x3"/>
   <p:notesSz cx="6858000" cy="9144000"/>
@@ -3222,7 +3221,7 @@
 </p:sld>
 </file>
 
-<file path=ppt/slides/slide10.xml><?xml version="1.0" encoding="utf-8"?>
+<file path=ppt/slides/slide2.xml><?xml version="1.0" encoding="utf-8"?>
 <p:sld xmlns:a="http://schemas.openxmlformats.org/drawingml/2006/main" xmlns:p="http://schemas.openxmlformats.org/presentationml/2006/main" xmlns:r="http://schemas.openxmlformats.org/officeDocument/2006/relationships">
   <p:cSld>
     <p:spTree>
@@ -3305,7 +3304,7 @@
               </a:defRPr>
             </a:pPr>
             <a:r>
-              <a:t>Appendix: Data Sources &amp; Commands</a:t>
+              <a:t>Executive Summary</a:t>
             </a:r>
           </a:p>
         </p:txBody>
@@ -3318,8 +3317,8 @@
         </p:nvSpPr>
         <p:spPr>
           <a:xfrm>
-            <a:off x="274320" y="914400"/>
-            <a:ext cx="11612880" cy="5669280"/>
+            <a:off x="457200" y="1097280"/>
+            <a:ext cx="11277295" cy="5486400"/>
           </a:xfrm>
           <a:prstGeom prst="rect">
             <a:avLst/>
@@ -3333,86 +3332,61 @@
           <a:lstStyle/>
           <a:p>
             <a:pPr>
-              <a:defRPr sz="1100">
-                <a:latin typeface="Consolas"/>
-              </a:defRPr>
+              <a:defRPr sz="1600"/>
             </a:pPr>
             <a:r>
-              <a:t>Data Collection Commands:</a:t>
-            </a:r>
-            <a:br/>
-            <a:br/>
-            <a:r>
-              <a:t>1st Pass Yield (no retest):</a:t>
-            </a:r>
-            <a:br/>
-            <a:r>
-              <a:t>frptx +regwidth +% +# -test_facility=all -dbase=y6cp +% +module -xf +# -sort=// \</a:t>
-            </a:r>
-            <a:br/>
-            <a:r>
-              <a:t>    -myquick=/MFG_WORKWEEK,DESIGN_ID,MODULE_FORM_FACTOR,MODULE_SPEED,MODULE_DENSITY/ \</a:t>
-            </a:r>
-            <a:br/>
-            <a:r>
-              <a:t>    +quick=/myquick,step/ +echo -bin=hard -step={step} -eng_summary=N/A \</a:t>
-            </a:r>
-            <a:br/>
-            <a:r>
-              <a:t>    -module_speed=7500MT -standard_flow=YES -module_form_factor=socamm2 \</a:t>
-            </a:r>
-            <a:br/>
-            <a:r>
-              <a:t>    -mfg_workweek=202608,202609,...,202617 -n -nonshippable=N/A +debug -top5</a:t>
-            </a:r>
-            <a:br/>
-            <a:br/>
-            <a:r>
-              <a:t>Final Pass Yield (with retest + imesh):</a:t>
-            </a:r>
-            <a:br/>
-            <a:r>
-              <a:t>... same as above ... -n +imesh -r ...</a:t>
-            </a:r>
-            <a:br/>
-            <a:br/>
-            <a:r>
-              <a:t>cDPM Data:</a:t>
-            </a:r>
-            <a:br/>
-            <a:r>
-              <a:t>mtsums -dbase=y6cp -step={step} -module_form_factor=socamm2 -module_speed=7500MTPS \</a:t>
-            </a:r>
-            <a:br/>
-            <a:r>
-              <a:t>    -mfg_workweek=202608,...,202617 +stdf +fm +fc</a:t>
-            </a:r>
-            <a:br/>
-            <a:br/>
-            <a:r>
-              <a:t>MSN_STATUS Breakdown:</a:t>
-            </a:r>
-            <a:br/>
-            <a:r>
-              <a:t>mtsums ... +msnag</a:t>
-            </a:r>
-            <a:br/>
-            <a:br/>
-            <a:r>
-              <a:t>FAILCRAWLER Correlation:</a:t>
-            </a:r>
-            <a:br/>
-            <a:r>
-              <a:t>mtsums ... +msnag -format=/msn_status,failcrawler/</a:t>
-            </a:r>
-            <a:br/>
-            <a:br/>
-            <a:r>
-              <a:t>RPx Verification:</a:t>
-            </a:r>
-            <a:br/>
-            <a:r>
-              <a:t>/home/nmewes/Y6CP_FA/socamm_false_miscompare.py --sums {slash_paths}</a:t>
+              <a:t>Key Findings (SOCAMM2 7500MT, 10-Week Cumulative):</a:t>
+            </a:r>
+            <a:br/>
+            <a:br/>
+            <a:r>
+              <a:t>HMB1 Step:</a:t>
+            </a:r>
+            <a:br/>
+            <a:r>
+              <a:t>• Yield: 98.32% (29,788 modules tested)</a:t>
+            </a:r>
+            <a:br/>
+            <a:r>
+              <a:t>• Total cDPM: 265.7 → Customer-Facing: 98.6 DPM</a:t>
+            </a:r>
+            <a:br/>
+            <a:r>
+              <a:t>• Recovery: 167.2 DPM (63% recoverable)</a:t>
+            </a:r>
+            <a:br/>
+            <a:br/>
+            <a:r>
+              <a:t>QMON Step:</a:t>
+            </a:r>
+            <a:br/>
+            <a:r>
+              <a:t>• Yield: 98.79% (24,126 modules tested)</a:t>
+            </a:r>
+            <a:br/>
+            <a:r>
+              <a:t>• Total cDPM: 191.2 → Customer-Facing: 59.4 DPM</a:t>
+            </a:r>
+            <a:br/>
+            <a:r>
+              <a:t>• Recovery: 131.8 DPM (69% recoverable)</a:t>
+            </a:r>
+            <a:br/>
+            <a:br/>
+            <a:r>
+              <a:t>Combined SLT (HMB1 × QMON):</a:t>
+            </a:r>
+            <a:br/>
+            <a:r>
+              <a:t>• Combined Yield: 97.13%</a:t>
+            </a:r>
+            <a:br/>
+            <a:r>
+              <a:t>• Total cDPM: 456.9 → Customer-Facing: 157.9 DPM</a:t>
+            </a:r>
+            <a:br/>
+            <a:r>
+              <a:t>• Total Recoverable: 298.9 DPM (65%)</a:t>
             </a:r>
           </a:p>
         </p:txBody>
@@ -3425,7 +3399,7 @@
 </p:sld>
 </file>
 
-<file path=ppt/slides/slide2.xml><?xml version="1.0" encoding="utf-8"?>
+<file path=ppt/slides/slide3.xml><?xml version="1.0" encoding="utf-8"?>
 <p:sld xmlns:a="http://schemas.openxmlformats.org/drawingml/2006/main" xmlns:p="http://schemas.openxmlformats.org/presentationml/2006/main" xmlns:r="http://schemas.openxmlformats.org/officeDocument/2006/relationships">
   <p:cSld>
     <p:spTree>
@@ -3508,21 +3482,563 @@
               </a:defRPr>
             </a:pPr>
             <a:r>
-              <a:t>Executive Summary</a:t>
-            </a:r>
-          </a:p>
-        </p:txBody>
-      </p:sp>
-      <p:sp>
-        <p:nvSpPr>
-          <p:cNvPr id="4" name="TextBox 3"/>
+              <a:t>MFG vs ENG View: Bridging the Communication Gap</a:t>
+            </a:r>
+          </a:p>
+        </p:txBody>
+      </p:sp>
+      <p:graphicFrame>
+        <p:nvGraphicFramePr>
+          <p:cNvPr id="4" name="Table 3"/>
+          <p:cNvGraphicFramePr>
+            <a:graphicFrameLocks noGrp="1"/>
+          </p:cNvGraphicFramePr>
+          <p:nvPr/>
+        </p:nvGraphicFramePr>
+        <p:xfrm>
+          <a:off x="1371600" y="1188720"/>
+          <a:ext cx="9144000" cy="2560320"/>
+        </p:xfrm>
+        <a:graphic>
+          <a:graphicData uri="http://schemas.openxmlformats.org/drawingml/2006/table">
+            <a:tbl>
+              <a:tblPr firstRow="1" bandRow="1">
+                <a:tableStyleId>{5C22544A-7EE6-4342-B048-85BDC9FD1C3A}</a:tableStyleId>
+              </a:tblPr>
+              <a:tblGrid>
+                <a:gridCol w="2286000"/>
+                <a:gridCol w="2286000"/>
+                <a:gridCol w="2286000"/>
+                <a:gridCol w="2286000"/>
+              </a:tblGrid>
+              <a:tr h="365760">
+                <a:tc>
+                  <a:txBody>
+                    <a:bodyPr/>
+                    <a:lstStyle/>
+                    <a:p>
+                      <a:pPr algn="ctr">
+                        <a:defRPr sz="1400" b="1">
+                          <a:solidFill>
+                            <a:srgbClr val="FFFFFF"/>
+                          </a:solidFill>
+                        </a:defRPr>
+                      </a:pPr>
+                      <a:r>
+                        <a:t>Metric</a:t>
+                      </a:r>
+                    </a:p>
+                  </a:txBody>
+                  <a:tcPr>
+                    <a:solidFill>
+                      <a:srgbClr val="003366"/>
+                    </a:solidFill>
+                  </a:tcPr>
+                </a:tc>
+                <a:tc>
+                  <a:txBody>
+                    <a:bodyPr/>
+                    <a:lstStyle/>
+                    <a:p>
+                      <a:pPr algn="ctr">
+                        <a:defRPr sz="1400" b="1">
+                          <a:solidFill>
+                            <a:srgbClr val="FFFFFF"/>
+                          </a:solidFill>
+                        </a:defRPr>
+                      </a:pPr>
+                      <a:r>
+                        <a:t>HMB1</a:t>
+                      </a:r>
+                    </a:p>
+                  </a:txBody>
+                  <a:tcPr>
+                    <a:solidFill>
+                      <a:srgbClr val="003366"/>
+                    </a:solidFill>
+                  </a:tcPr>
+                </a:tc>
+                <a:tc>
+                  <a:txBody>
+                    <a:bodyPr/>
+                    <a:lstStyle/>
+                    <a:p>
+                      <a:pPr algn="ctr">
+                        <a:defRPr sz="1400" b="1">
+                          <a:solidFill>
+                            <a:srgbClr val="FFFFFF"/>
+                          </a:solidFill>
+                        </a:defRPr>
+                      </a:pPr>
+                      <a:r>
+                        <a:t>QMON</a:t>
+                      </a:r>
+                    </a:p>
+                  </a:txBody>
+                  <a:tcPr>
+                    <a:solidFill>
+                      <a:srgbClr val="003366"/>
+                    </a:solidFill>
+                  </a:tcPr>
+                </a:tc>
+                <a:tc>
+                  <a:txBody>
+                    <a:bodyPr/>
+                    <a:lstStyle/>
+                    <a:p>
+                      <a:pPr algn="ctr">
+                        <a:defRPr sz="1400" b="1">
+                          <a:solidFill>
+                            <a:srgbClr val="FFFFFF"/>
+                          </a:solidFill>
+                        </a:defRPr>
+                      </a:pPr>
+                      <a:r>
+                        <a:t>Combined SLT</a:t>
+                      </a:r>
+                    </a:p>
+                  </a:txBody>
+                  <a:tcPr>
+                    <a:solidFill>
+                      <a:srgbClr val="003366"/>
+                    </a:solidFill>
+                  </a:tcPr>
+                </a:tc>
+              </a:tr>
+              <a:tr h="365760">
+                <a:tc>
+                  <a:txBody>
+                    <a:bodyPr/>
+                    <a:lstStyle/>
+                    <a:p>
+                      <a:pPr algn="ctr">
+                        <a:defRPr sz="1400" b="1"/>
+                      </a:pPr>
+                      <a:r>
+                        <a:t>MFG View (Yield %)</a:t>
+                      </a:r>
+                    </a:p>
+                  </a:txBody>
+                  <a:tcPr>
+                    <a:solidFill>
+                      <a:srgbClr val="C6E0B4"/>
+                    </a:solidFill>
+                  </a:tcPr>
+                </a:tc>
+                <a:tc>
+                  <a:txBody>
+                    <a:bodyPr/>
+                    <a:lstStyle/>
+                    <a:p>
+                      <a:pPr algn="ctr">
+                        <a:defRPr sz="1400" b="1"/>
+                      </a:pPr>
+                      <a:r>
+                        <a:t>98.32%</a:t>
+                      </a:r>
+                    </a:p>
+                  </a:txBody>
+                  <a:tcPr>
+                    <a:solidFill>
+                      <a:srgbClr val="C6E0B4"/>
+                    </a:solidFill>
+                  </a:tcPr>
+                </a:tc>
+                <a:tc>
+                  <a:txBody>
+                    <a:bodyPr/>
+                    <a:lstStyle/>
+                    <a:p>
+                      <a:pPr algn="ctr">
+                        <a:defRPr sz="1400" b="1"/>
+                      </a:pPr>
+                      <a:r>
+                        <a:t>98.79%</a:t>
+                      </a:r>
+                    </a:p>
+                  </a:txBody>
+                  <a:tcPr>
+                    <a:solidFill>
+                      <a:srgbClr val="C6E0B4"/>
+                    </a:solidFill>
+                  </a:tcPr>
+                </a:tc>
+                <a:tc>
+                  <a:txBody>
+                    <a:bodyPr/>
+                    <a:lstStyle/>
+                    <a:p>
+                      <a:pPr algn="ctr">
+                        <a:defRPr sz="1400" b="1"/>
+                      </a:pPr>
+                      <a:r>
+                        <a:t>97.13%</a:t>
+                      </a:r>
+                    </a:p>
+                  </a:txBody>
+                  <a:tcPr>
+                    <a:solidFill>
+                      <a:srgbClr val="C6E0B4"/>
+                    </a:solidFill>
+                  </a:tcPr>
+                </a:tc>
+              </a:tr>
+              <a:tr h="365760">
+                <a:tc>
+                  <a:txBody>
+                    <a:bodyPr/>
+                    <a:lstStyle/>
+                    <a:p>
+                      <a:pPr algn="ctr">
+                        <a:defRPr sz="1400"/>
+                      </a:pPr>
+                      <a:r>
+                        <a:t>Modules Tested</a:t>
+                      </a:r>
+                    </a:p>
+                  </a:txBody>
+                  <a:tcPr/>
+                </a:tc>
+                <a:tc>
+                  <a:txBody>
+                    <a:bodyPr/>
+                    <a:lstStyle/>
+                    <a:p>
+                      <a:pPr algn="ctr">
+                        <a:defRPr sz="1400"/>
+                      </a:pPr>
+                      <a:r>
+                        <a:t>29,788</a:t>
+                      </a:r>
+                    </a:p>
+                  </a:txBody>
+                  <a:tcPr/>
+                </a:tc>
+                <a:tc>
+                  <a:txBody>
+                    <a:bodyPr/>
+                    <a:lstStyle/>
+                    <a:p>
+                      <a:pPr algn="ctr">
+                        <a:defRPr sz="1400"/>
+                      </a:pPr>
+                      <a:r>
+                        <a:t>24,126</a:t>
+                      </a:r>
+                    </a:p>
+                  </a:txBody>
+                  <a:tcPr/>
+                </a:tc>
+                <a:tc>
+                  <a:txBody>
+                    <a:bodyPr/>
+                    <a:lstStyle/>
+                    <a:p>
+                      <a:pPr algn="ctr">
+                        <a:defRPr sz="1400"/>
+                      </a:pPr>
+                      <a:r>
+                        <a:t>-</a:t>
+                      </a:r>
+                    </a:p>
+                  </a:txBody>
+                  <a:tcPr/>
+                </a:tc>
+              </a:tr>
+              <a:tr h="365760">
+                <a:tc>
+                  <a:txBody>
+                    <a:bodyPr/>
+                    <a:lstStyle/>
+                    <a:p>
+                      <a:pPr algn="ctr">
+                        <a:defRPr sz="1400"/>
+                      </a:pPr>
+                      <a:r>
+                        <a:t>Modules Failed</a:t>
+                      </a:r>
+                    </a:p>
+                  </a:txBody>
+                  <a:tcPr/>
+                </a:tc>
+                <a:tc>
+                  <a:txBody>
+                    <a:bodyPr/>
+                    <a:lstStyle/>
+                    <a:p>
+                      <a:pPr algn="ctr">
+                        <a:defRPr sz="1400"/>
+                      </a:pPr>
+                      <a:r>
+                        <a:t>500</a:t>
+                      </a:r>
+                    </a:p>
+                  </a:txBody>
+                  <a:tcPr/>
+                </a:tc>
+                <a:tc>
+                  <a:txBody>
+                    <a:bodyPr/>
+                    <a:lstStyle/>
+                    <a:p>
+                      <a:pPr algn="ctr">
+                        <a:defRPr sz="1400"/>
+                      </a:pPr>
+                      <a:r>
+                        <a:t>292</a:t>
+                      </a:r>
+                    </a:p>
+                  </a:txBody>
+                  <a:tcPr/>
+                </a:tc>
+                <a:tc>
+                  <a:txBody>
+                    <a:bodyPr/>
+                    <a:lstStyle/>
+                    <a:p>
+                      <a:pPr algn="ctr">
+                        <a:defRPr sz="1400"/>
+                      </a:pPr>
+                      <a:r>
+                        <a:t>792</a:t>
+                      </a:r>
+                    </a:p>
+                  </a:txBody>
+                  <a:tcPr/>
+                </a:tc>
+              </a:tr>
+              <a:tr h="365760">
+                <a:tc>
+                  <a:txBody>
+                    <a:bodyPr/>
+                    <a:lstStyle/>
+                    <a:p>
+                      <a:pPr algn="ctr">
+                        <a:defRPr sz="1400" b="1"/>
+                      </a:pPr>
+                      <a:r>
+                        <a:t>ENG View (cDPM)</a:t>
+                      </a:r>
+                    </a:p>
+                  </a:txBody>
+                  <a:tcPr>
+                    <a:solidFill>
+                      <a:srgbClr val="FFC7CE"/>
+                    </a:solidFill>
+                  </a:tcPr>
+                </a:tc>
+                <a:tc>
+                  <a:txBody>
+                    <a:bodyPr/>
+                    <a:lstStyle/>
+                    <a:p>
+                      <a:pPr algn="ctr">
+                        <a:defRPr sz="1400" b="1"/>
+                      </a:pPr>
+                      <a:r>
+                        <a:t>265.7</a:t>
+                      </a:r>
+                    </a:p>
+                  </a:txBody>
+                  <a:tcPr>
+                    <a:solidFill>
+                      <a:srgbClr val="FFC7CE"/>
+                    </a:solidFill>
+                  </a:tcPr>
+                </a:tc>
+                <a:tc>
+                  <a:txBody>
+                    <a:bodyPr/>
+                    <a:lstStyle/>
+                    <a:p>
+                      <a:pPr algn="ctr">
+                        <a:defRPr sz="1400" b="1"/>
+                      </a:pPr>
+                      <a:r>
+                        <a:t>191.2</a:t>
+                      </a:r>
+                    </a:p>
+                  </a:txBody>
+                  <a:tcPr>
+                    <a:solidFill>
+                      <a:srgbClr val="FFC7CE"/>
+                    </a:solidFill>
+                  </a:tcPr>
+                </a:tc>
+                <a:tc>
+                  <a:txBody>
+                    <a:bodyPr/>
+                    <a:lstStyle/>
+                    <a:p>
+                      <a:pPr algn="ctr">
+                        <a:defRPr sz="1400" b="1"/>
+                      </a:pPr>
+                      <a:r>
+                        <a:t>456.9</a:t>
+                      </a:r>
+                    </a:p>
+                  </a:txBody>
+                  <a:tcPr>
+                    <a:solidFill>
+                      <a:srgbClr val="FFC7CE"/>
+                    </a:solidFill>
+                  </a:tcPr>
+                </a:tc>
+              </a:tr>
+              <a:tr h="365760">
+                <a:tc>
+                  <a:txBody>
+                    <a:bodyPr/>
+                    <a:lstStyle/>
+                    <a:p>
+                      <a:pPr algn="ctr">
+                        <a:defRPr sz="1400"/>
+                      </a:pPr>
+                      <a:r>
+                        <a:t>Recoverable DPM</a:t>
+                      </a:r>
+                    </a:p>
+                  </a:txBody>
+                  <a:tcPr/>
+                </a:tc>
+                <a:tc>
+                  <a:txBody>
+                    <a:bodyPr/>
+                    <a:lstStyle/>
+                    <a:p>
+                      <a:pPr algn="ctr">
+                        <a:defRPr sz="1400"/>
+                      </a:pPr>
+                      <a:r>
+                        <a:t>167.2</a:t>
+                      </a:r>
+                    </a:p>
+                  </a:txBody>
+                  <a:tcPr/>
+                </a:tc>
+                <a:tc>
+                  <a:txBody>
+                    <a:bodyPr/>
+                    <a:lstStyle/>
+                    <a:p>
+                      <a:pPr algn="ctr">
+                        <a:defRPr sz="1400"/>
+                      </a:pPr>
+                      <a:r>
+                        <a:t>131.8</a:t>
+                      </a:r>
+                    </a:p>
+                  </a:txBody>
+                  <a:tcPr/>
+                </a:tc>
+                <a:tc>
+                  <a:txBody>
+                    <a:bodyPr/>
+                    <a:lstStyle/>
+                    <a:p>
+                      <a:pPr algn="ctr">
+                        <a:defRPr sz="1400"/>
+                      </a:pPr>
+                      <a:r>
+                        <a:t>298.9</a:t>
+                      </a:r>
+                    </a:p>
+                  </a:txBody>
+                  <a:tcPr/>
+                </a:tc>
+              </a:tr>
+              <a:tr h="365760">
+                <a:tc>
+                  <a:txBody>
+                    <a:bodyPr/>
+                    <a:lstStyle/>
+                    <a:p>
+                      <a:pPr algn="ctr">
+                        <a:defRPr sz="1400" b="1"/>
+                      </a:pPr>
+                      <a:r>
+                        <a:t>Customer-Facing DPM</a:t>
+                      </a:r>
+                    </a:p>
+                  </a:txBody>
+                  <a:tcPr>
+                    <a:solidFill>
+                      <a:srgbClr val="FFEB9C"/>
+                    </a:solidFill>
+                  </a:tcPr>
+                </a:tc>
+                <a:tc>
+                  <a:txBody>
+                    <a:bodyPr/>
+                    <a:lstStyle/>
+                    <a:p>
+                      <a:pPr algn="ctr">
+                        <a:defRPr sz="1400" b="1"/>
+                      </a:pPr>
+                      <a:r>
+                        <a:t>98.6</a:t>
+                      </a:r>
+                    </a:p>
+                  </a:txBody>
+                  <a:tcPr>
+                    <a:solidFill>
+                      <a:srgbClr val="FFEB9C"/>
+                    </a:solidFill>
+                  </a:tcPr>
+                </a:tc>
+                <a:tc>
+                  <a:txBody>
+                    <a:bodyPr/>
+                    <a:lstStyle/>
+                    <a:p>
+                      <a:pPr algn="ctr">
+                        <a:defRPr sz="1400" b="1"/>
+                      </a:pPr>
+                      <a:r>
+                        <a:t>59.4</a:t>
+                      </a:r>
+                    </a:p>
+                  </a:txBody>
+                  <a:tcPr>
+                    <a:solidFill>
+                      <a:srgbClr val="FFEB9C"/>
+                    </a:solidFill>
+                  </a:tcPr>
+                </a:tc>
+                <a:tc>
+                  <a:txBody>
+                    <a:bodyPr/>
+                    <a:lstStyle/>
+                    <a:p>
+                      <a:pPr algn="ctr">
+                        <a:defRPr sz="1400" b="1"/>
+                      </a:pPr>
+                      <a:r>
+                        <a:t>157.9</a:t>
+                      </a:r>
+                    </a:p>
+                  </a:txBody>
+                  <a:tcPr>
+                    <a:solidFill>
+                      <a:srgbClr val="FFEB9C"/>
+                    </a:solidFill>
+                  </a:tcPr>
+                </a:tc>
+              </a:tr>
+            </a:tbl>
+          </a:graphicData>
+        </a:graphic>
+      </p:graphicFrame>
+      <p:sp>
+        <p:nvSpPr>
+          <p:cNvPr id="5" name="TextBox 4"/>
           <p:cNvSpPr txBox="1"/>
           <p:nvPr/>
         </p:nvSpPr>
         <p:spPr>
           <a:xfrm>
-            <a:off x="457200" y="1097280"/>
-            <a:ext cx="11277295" cy="5486400"/>
+            <a:off x="457200" y="4114800"/>
+            <a:ext cx="11277295" cy="1371600"/>
           </a:xfrm>
           <a:prstGeom prst="rect">
             <a:avLst/>
@@ -3536,65 +4052,18 @@
           <a:lstStyle/>
           <a:p>
             <a:pPr>
-              <a:defRPr sz="1600">
-                <a:solidFill>
-                  <a:srgbClr val="000000"/>
-                </a:solidFill>
-              </a:defRPr>
+              <a:defRPr sz="1600" b="1"/>
             </a:pPr>
             <a:r>
-              <a:t>Key Findings (SOCAMM2 7500MT, 10-Week Cumulative):</a:t>
-            </a:r>
-            <a:br/>
-            <a:br/>
-            <a:r>
-              <a:t>HMB1 Step:</a:t>
-            </a:r>
-            <a:br/>
-            <a:r>
-              <a:t>• 1st Pass Yield: 98.71% → Final Pass: 98.63%</a:t>
-            </a:r>
-            <a:br/>
-            <a:r>
-              <a:t>• Total cDPM: 264.8 → Customer-Facing: 97.7 DPM</a:t>
-            </a:r>
-            <a:br/>
-            <a:r>
-              <a:t>• Recovery: 167.2 DPM (63.1%)</a:t>
-            </a:r>
-            <a:br/>
-            <a:br/>
-            <a:r>
-              <a:t>QMON Step:</a:t>
-            </a:r>
-            <a:br/>
-            <a:r>
-              <a:t>• 1st Pass Yield: 98.88% → Final Pass: 98.83%</a:t>
-            </a:r>
-            <a:br/>
-            <a:r>
-              <a:t>• Total cDPM: 191.2 → Customer-Facing: 59.4 DPM</a:t>
-            </a:r>
-            <a:br/>
-            <a:r>
-              <a:t>• Recovery: 131.8 DPM (68.9%)</a:t>
-            </a:r>
-            <a:br/>
-            <a:br/>
-            <a:r>
-              <a:t>Combined SLT (HMB1 × QMON):</a:t>
-            </a:r>
-            <a:br/>
-            <a:r>
-              <a:t>• Total cDPM: 456.0</a:t>
-            </a:r>
-            <a:br/>
-            <a:r>
-              <a:t>• Total Recovered: 298.9 DPM</a:t>
-            </a:r>
-            <a:br/>
-            <a:r>
-              <a:t>• Customer-Facing: 157.1 DPM</a:t>
+              <a:t>Key Message:</a:t>
+            </a:r>
+            <a:br/>
+            <a:r>
+              <a:t>MFG sees 97.1% yield (meeting shipping targets), but ENG sees 456.9 cDPM total risk.</a:t>
+            </a:r>
+            <a:br/>
+            <a:r>
+              <a:t>Through BIOS/HW+SOP recovery mechanisms, we reduce customer-facing risk to 157.9 cDPM.</a:t>
             </a:r>
           </a:p>
         </p:txBody>
@@ -3607,7 +4076,7 @@
 </p:sld>
 </file>
 
-<file path=ppt/slides/slide3.xml><?xml version="1.0" encoding="utf-8"?>
+<file path=ppt/slides/slide4.xml><?xml version="1.0" encoding="utf-8"?>
 <p:sld xmlns:a="http://schemas.openxmlformats.org/drawingml/2006/main" xmlns:p="http://schemas.openxmlformats.org/presentationml/2006/main" xmlns:r="http://schemas.openxmlformats.org/officeDocument/2006/relationships">
   <p:cSld>
     <p:spTree>
@@ -3690,375 +4159,21 @@
               </a:defRPr>
             </a:pPr>
             <a:r>
-              <a:t>MFG Yield: 1st Pass vs Final Pass</a:t>
-            </a:r>
-          </a:p>
-        </p:txBody>
-      </p:sp>
-      <p:graphicFrame>
-        <p:nvGraphicFramePr>
-          <p:cNvPr id="4" name="Table 3"/>
-          <p:cNvGraphicFramePr>
-            <a:graphicFrameLocks noGrp="1"/>
-          </p:cNvGraphicFramePr>
-          <p:nvPr/>
-        </p:nvGraphicFramePr>
-        <p:xfrm>
-          <a:off x="457200" y="1188720"/>
-          <a:ext cx="11277295" cy="1371600"/>
-        </p:xfrm>
-        <a:graphic>
-          <a:graphicData uri="http://schemas.openxmlformats.org/drawingml/2006/table">
-            <a:tbl>
-              <a:tblPr firstRow="1" bandRow="1">
-                <a:tableStyleId>{5C22544A-7EE6-4342-B048-85BDC9FD1C3A}</a:tableStyleId>
-              </a:tblPr>
-              <a:tblGrid>
-                <a:gridCol w="1879549"/>
-                <a:gridCol w="1879549"/>
-                <a:gridCol w="1879549"/>
-                <a:gridCol w="1879549"/>
-                <a:gridCol w="1879549"/>
-                <a:gridCol w="1879550"/>
-              </a:tblGrid>
-              <a:tr h="457200">
-                <a:tc>
-                  <a:txBody>
-                    <a:bodyPr/>
-                    <a:lstStyle/>
-                    <a:p>
-                      <a:pPr algn="ctr">
-                        <a:defRPr sz="1400" b="1">
-                          <a:solidFill>
-                            <a:srgbClr val="FFFFFF"/>
-                          </a:solidFill>
-                        </a:defRPr>
-                      </a:pPr>
-                      <a:r>
-                        <a:t>Step</a:t>
-                      </a:r>
-                    </a:p>
-                  </a:txBody>
-                  <a:tcPr>
-                    <a:solidFill>
-                      <a:srgbClr val="003366"/>
-                    </a:solidFill>
-                  </a:tcPr>
-                </a:tc>
-                <a:tc>
-                  <a:txBody>
-                    <a:bodyPr/>
-                    <a:lstStyle/>
-                    <a:p>
-                      <a:pPr algn="ctr">
-                        <a:defRPr sz="1400" b="1">
-                          <a:solidFill>
-                            <a:srgbClr val="FFFFFF"/>
-                          </a:solidFill>
-                        </a:defRPr>
-                      </a:pPr>
-                      <a:r>
-                        <a:t>1st Pass UIN</a:t>
-                      </a:r>
-                    </a:p>
-                  </a:txBody>
-                  <a:tcPr>
-                    <a:solidFill>
-                      <a:srgbClr val="003366"/>
-                    </a:solidFill>
-                  </a:tcPr>
-                </a:tc>
-                <a:tc>
-                  <a:txBody>
-                    <a:bodyPr/>
-                    <a:lstStyle/>
-                    <a:p>
-                      <a:pPr algn="ctr">
-                        <a:defRPr sz="1400" b="1">
-                          <a:solidFill>
-                            <a:srgbClr val="FFFFFF"/>
-                          </a:solidFill>
-                        </a:defRPr>
-                      </a:pPr>
-                      <a:r>
-                        <a:t>1st Pass Yield</a:t>
-                      </a:r>
-                    </a:p>
-                  </a:txBody>
-                  <a:tcPr>
-                    <a:solidFill>
-                      <a:srgbClr val="003366"/>
-                    </a:solidFill>
-                  </a:tcPr>
-                </a:tc>
-                <a:tc>
-                  <a:txBody>
-                    <a:bodyPr/>
-                    <a:lstStyle/>
-                    <a:p>
-                      <a:pPr algn="ctr">
-                        <a:defRPr sz="1400" b="1">
-                          <a:solidFill>
-                            <a:srgbClr val="FFFFFF"/>
-                          </a:solidFill>
-                        </a:defRPr>
-                      </a:pPr>
-                      <a:r>
-                        <a:t>Final Pass UIN</a:t>
-                      </a:r>
-                    </a:p>
-                  </a:txBody>
-                  <a:tcPr>
-                    <a:solidFill>
-                      <a:srgbClr val="003366"/>
-                    </a:solidFill>
-                  </a:tcPr>
-                </a:tc>
-                <a:tc>
-                  <a:txBody>
-                    <a:bodyPr/>
-                    <a:lstStyle/>
-                    <a:p>
-                      <a:pPr algn="ctr">
-                        <a:defRPr sz="1400" b="1">
-                          <a:solidFill>
-                            <a:srgbClr val="FFFFFF"/>
-                          </a:solidFill>
-                        </a:defRPr>
-                      </a:pPr>
-                      <a:r>
-                        <a:t>Final Pass Yield</a:t>
-                      </a:r>
-                    </a:p>
-                  </a:txBody>
-                  <a:tcPr>
-                    <a:solidFill>
-                      <a:srgbClr val="003366"/>
-                    </a:solidFill>
-                  </a:tcPr>
-                </a:tc>
-                <a:tc>
-                  <a:txBody>
-                    <a:bodyPr/>
-                    <a:lstStyle/>
-                    <a:p>
-                      <a:pPr algn="ctr">
-                        <a:defRPr sz="1400" b="1">
-                          <a:solidFill>
-                            <a:srgbClr val="FFFFFF"/>
-                          </a:solidFill>
-                        </a:defRPr>
-                      </a:pPr>
-                      <a:r>
-                        <a:t>Retest Gain</a:t>
-                      </a:r>
-                    </a:p>
-                  </a:txBody>
-                  <a:tcPr>
-                    <a:solidFill>
-                      <a:srgbClr val="003366"/>
-                    </a:solidFill>
-                  </a:tcPr>
-                </a:tc>
-              </a:tr>
-              <a:tr h="457200">
-                <a:tc>
-                  <a:txBody>
-                    <a:bodyPr/>
-                    <a:lstStyle/>
-                    <a:p>
-                      <a:pPr algn="ctr">
-                        <a:defRPr sz="1400"/>
-                      </a:pPr>
-                      <a:r>
-                        <a:t>HMB1</a:t>
-                      </a:r>
-                    </a:p>
-                  </a:txBody>
-                  <a:tcPr/>
-                </a:tc>
-                <a:tc>
-                  <a:txBody>
-                    <a:bodyPr/>
-                    <a:lstStyle/>
-                    <a:p>
-                      <a:pPr algn="ctr">
-                        <a:defRPr sz="1400"/>
-                      </a:pPr>
-                      <a:r>
-                        <a:t>37,118</a:t>
-                      </a:r>
-                    </a:p>
-                  </a:txBody>
-                  <a:tcPr/>
-                </a:tc>
-                <a:tc>
-                  <a:txBody>
-                    <a:bodyPr/>
-                    <a:lstStyle/>
-                    <a:p>
-                      <a:pPr algn="ctr">
-                        <a:defRPr sz="1400"/>
-                      </a:pPr>
-                      <a:r>
-                        <a:t>98.71%</a:t>
-                      </a:r>
-                    </a:p>
-                  </a:txBody>
-                  <a:tcPr/>
-                </a:tc>
-                <a:tc>
-                  <a:txBody>
-                    <a:bodyPr/>
-                    <a:lstStyle/>
-                    <a:p>
-                      <a:pPr algn="ctr">
-                        <a:defRPr sz="1400"/>
-                      </a:pPr>
-                      <a:r>
-                        <a:t>32,016</a:t>
-                      </a:r>
-                    </a:p>
-                  </a:txBody>
-                  <a:tcPr/>
-                </a:tc>
-                <a:tc>
-                  <a:txBody>
-                    <a:bodyPr/>
-                    <a:lstStyle/>
-                    <a:p>
-                      <a:pPr algn="ctr">
-                        <a:defRPr sz="1400"/>
-                      </a:pPr>
-                      <a:r>
-                        <a:t>98.63%</a:t>
-                      </a:r>
-                    </a:p>
-                  </a:txBody>
-                  <a:tcPr/>
-                </a:tc>
-                <a:tc>
-                  <a:txBody>
-                    <a:bodyPr/>
-                    <a:lstStyle/>
-                    <a:p>
-                      <a:pPr algn="ctr">
-                        <a:defRPr sz="1400"/>
-                      </a:pPr>
-                      <a:r>
-                        <a:t>-0.08%</a:t>
-                      </a:r>
-                    </a:p>
-                  </a:txBody>
-                  <a:tcPr/>
-                </a:tc>
-              </a:tr>
-              <a:tr h="457200">
-                <a:tc>
-                  <a:txBody>
-                    <a:bodyPr/>
-                    <a:lstStyle/>
-                    <a:p>
-                      <a:pPr algn="ctr">
-                        <a:defRPr sz="1400"/>
-                      </a:pPr>
-                      <a:r>
-                        <a:t>QMON</a:t>
-                      </a:r>
-                    </a:p>
-                  </a:txBody>
-                  <a:tcPr/>
-                </a:tc>
-                <a:tc>
-                  <a:txBody>
-                    <a:bodyPr/>
-                    <a:lstStyle/>
-                    <a:p>
-                      <a:pPr algn="ctr">
-                        <a:defRPr sz="1400"/>
-                      </a:pPr>
-                      <a:r>
-                        <a:t>27,128</a:t>
-                      </a:r>
-                    </a:p>
-                  </a:txBody>
-                  <a:tcPr/>
-                </a:tc>
-                <a:tc>
-                  <a:txBody>
-                    <a:bodyPr/>
-                    <a:lstStyle/>
-                    <a:p>
-                      <a:pPr algn="ctr">
-                        <a:defRPr sz="1400"/>
-                      </a:pPr>
-                      <a:r>
-                        <a:t>98.88%</a:t>
-                      </a:r>
-                    </a:p>
-                  </a:txBody>
-                  <a:tcPr/>
-                </a:tc>
-                <a:tc>
-                  <a:txBody>
-                    <a:bodyPr/>
-                    <a:lstStyle/>
-                    <a:p>
-                      <a:pPr algn="ctr">
-                        <a:defRPr sz="1400"/>
-                      </a:pPr>
-                      <a:r>
-                        <a:t>25,450</a:t>
-                      </a:r>
-                    </a:p>
-                  </a:txBody>
-                  <a:tcPr/>
-                </a:tc>
-                <a:tc>
-                  <a:txBody>
-                    <a:bodyPr/>
-                    <a:lstStyle/>
-                    <a:p>
-                      <a:pPr algn="ctr">
-                        <a:defRPr sz="1400"/>
-                      </a:pPr>
-                      <a:r>
-                        <a:t>98.83%</a:t>
-                      </a:r>
-                    </a:p>
-                  </a:txBody>
-                  <a:tcPr/>
-                </a:tc>
-                <a:tc>
-                  <a:txBody>
-                    <a:bodyPr/>
-                    <a:lstStyle/>
-                    <a:p>
-                      <a:pPr algn="ctr">
-                        <a:defRPr sz="1400"/>
-                      </a:pPr>
-                      <a:r>
-                        <a:t>-0.05%</a:t>
-                      </a:r>
-                    </a:p>
-                  </a:txBody>
-                  <a:tcPr/>
-                </a:tc>
-              </a:tr>
-            </a:tbl>
-          </a:graphicData>
-        </a:graphic>
-      </p:graphicFrame>
-      <p:sp>
-        <p:nvSpPr>
-          <p:cNvPr id="5" name="TextBox 4"/>
+              <a:t>DPM Calculation: Kevin Roos Method</a:t>
+            </a:r>
+          </a:p>
+        </p:txBody>
+      </p:sp>
+      <p:sp>
+        <p:nvSpPr>
+          <p:cNvPr id="4" name="TextBox 3"/>
           <p:cNvSpPr txBox="1"/>
           <p:nvPr/>
         </p:nvSpPr>
         <p:spPr>
           <a:xfrm>
-            <a:off x="457200" y="2926080"/>
-            <a:ext cx="11277295" cy="1828800"/>
+            <a:off x="457200" y="1005840"/>
+            <a:ext cx="11277295" cy="5486400"/>
           </a:xfrm>
           <a:prstGeom prst="rect">
             <a:avLst/>
@@ -4072,26 +4187,72 @@
           <a:lstStyle/>
           <a:p>
             <a:pPr>
-              <a:defRPr sz="1400"/>
+              <a:defRPr sz="1400">
+                <a:latin typeface="Consolas"/>
+              </a:defRPr>
             </a:pPr>
             <a:r>
-              <a:t>Key Notes:</a:t>
-            </a:r>
-            <a:br/>
-            <a:r>
-              <a:t>• 1st Pass (-n): No retest, no imesh - raw first-time pass yield</a:t>
-            </a:r>
-            <a:br/>
-            <a:r>
-              <a:t>• Final Pass (-n -r +imesh): With retest and imesh overlay - actual shipping yield</a:t>
-            </a:r>
-            <a:br/>
-            <a:r>
-              <a:t>• Retest Gain shows the yield improvement from retest program</a:t>
-            </a:r>
-            <a:br/>
-            <a:r>
-              <a:t>• UIN difference: imesh excludes modules already passing at earlier steps</a:t>
+              <a:t>Formula:</a:t>
+            </a:r>
+            <a:br/>
+            <a:r>
+              <a:t>                    Unique Failing MSNs</a:t>
+            </a:r>
+            <a:br/>
+            <a:r>
+              <a:t>        cDPM = ─────────────────────────── × 1,000,000</a:t>
+            </a:r>
+            <a:br/>
+            <a:r>
+              <a:t>                      Total FID UIN</a:t>
+            </a:r>
+            <a:br/>
+            <a:br/>
+            <a:r>
+              <a:t>Calculation:</a:t>
+            </a:r>
+            <a:br/>
+            <a:br/>
+            <a:r>
+              <a:t>HMB1:</a:t>
+            </a:r>
+            <a:br/>
+            <a:r>
+              <a:t>    cDPM = 500 unique failing modules / 1,881,631 total FIDs × 1,000,000</a:t>
+            </a:r>
+            <a:br/>
+            <a:r>
+              <a:t>         = 265.73 DPM</a:t>
+            </a:r>
+            <a:br/>
+            <a:br/>
+            <a:r>
+              <a:t>QMON:</a:t>
+            </a:r>
+            <a:br/>
+            <a:r>
+              <a:t>    cDPM = 292 unique failing modules / 1,527,576 total FIDs × 1,000,000</a:t>
+            </a:r>
+            <a:br/>
+            <a:r>
+              <a:t>         = 191.15 DPM</a:t>
+            </a:r>
+            <a:br/>
+            <a:br/>
+            <a:r>
+              <a:t>Key Points:</a:t>
+            </a:r>
+            <a:br/>
+            <a:r>
+              <a:t>• Numerator: Count of unique MSNs (modules) with failures - each module counted ONCE</a:t>
+            </a:r>
+            <a:br/>
+            <a:r>
+              <a:t>• Denominator: Total FID UIN (component population) from mtsums +fidag</a:t>
+            </a:r>
+            <a:br/>
+            <a:r>
+              <a:t>• This gives component-level perspective while counting module-level failures</a:t>
             </a:r>
           </a:p>
         </p:txBody>
@@ -4104,7 +4265,7 @@
 </p:sld>
 </file>
 
-<file path=ppt/slides/slide4.xml><?xml version="1.0" encoding="utf-8"?>
+<file path=ppt/slides/slide5.xml><?xml version="1.0" encoding="utf-8"?>
 <p:sld xmlns:a="http://schemas.openxmlformats.org/drawingml/2006/main" xmlns:p="http://schemas.openxmlformats.org/presentationml/2006/main" xmlns:r="http://schemas.openxmlformats.org/officeDocument/2006/relationships">
   <p:cSld>
     <p:spTree>
@@ -4187,7 +4348,7 @@
               </a:defRPr>
             </a:pPr>
             <a:r>
-              <a:t>cDPM by FAILCRAWLER Category</a:t>
+              <a:t>Top FAILCRAWLER Categories by DPM</a:t>
             </a:r>
           </a:p>
         </p:txBody>
@@ -4201,7 +4362,7 @@
         <p:spPr>
           <a:xfrm>
             <a:off x="457200" y="1097280"/>
-            <a:ext cx="5486400" cy="5029200"/>
+            <a:ext cx="5486400" cy="4572000"/>
           </a:xfrm>
           <a:prstGeom prst="rect">
             <a:avLst/>
@@ -4215,50 +4376,46 @@
           <a:lstStyle/>
           <a:p>
             <a:pPr>
-              <a:defRPr sz="1400"/>
+              <a:defRPr sz="1300"/>
             </a:pPr>
             <a:r>
-              <a:t>HMB1 (Total: 264.8 DPM)</a:t>
-            </a:r>
-            <a:br/>
-            <a:r>
-              <a:t>• MULTI_BANK_MULTI_DQ: 98.0 DPM</a:t>
-            </a:r>
-            <a:br/>
-            <a:r>
-              <a:t>• SINGLE_BURST_SINGLE_ROW: 46.3 DPM</a:t>
-            </a:r>
-            <a:br/>
-            <a:r>
-              <a:t>• HGDC: 41.6 DPM</a:t>
-            </a:r>
-            <a:br/>
-            <a:r>
-              <a:t>• HANG: 15.9 DPM</a:t>
-            </a:r>
-            <a:br/>
-            <a:r>
-              <a:t>• SYS_EVEN_BURST_BIT: 12.8 DPM</a:t>
-            </a:r>
-            <a:br/>
-            <a:r>
-              <a:t>• MULTI_HALFBANK_SINGLE_DQ: 8.7 DPM</a:t>
-            </a:r>
-            <a:br/>
-            <a:r>
-              <a:t>• UNKNOWN: 7.4 DPM</a:t>
-            </a:r>
-            <a:br/>
-            <a:r>
-              <a:t>• MULTI_HALFBANK_MULTI_DQ: 6.2 DPM</a:t>
-            </a:r>
-            <a:br/>
-            <a:r>
-              <a:t>• SB: 4.8 DPM</a:t>
-            </a:r>
-            <a:br/>
-            <a:r>
-              <a:t>• DB: 4.6 DPM</a:t>
+              <a:t>HMB1 (Total: 265.7 DPM)</a:t>
+            </a:r>
+            <a:br/>
+            <a:r>
+              <a:t>───────────────────────────────────</a:t>
+            </a:r>
+            <a:br/>
+            <a:r>
+              <a:t>• MULTI_BANK_MULTI_DQ: 98.0 DPM (37%)</a:t>
+            </a:r>
+            <a:br/>
+            <a:r>
+              <a:t>• SINGLE_BURST_SINGLE_ROW: 46.3 DPM (17%)</a:t>
+            </a:r>
+            <a:br/>
+            <a:r>
+              <a:t>• HGDC: 41.6 DPM (16%)</a:t>
+            </a:r>
+            <a:br/>
+            <a:r>
+              <a:t>• HANG: 15.9 DPM (6%)</a:t>
+            </a:r>
+            <a:br/>
+            <a:r>
+              <a:t>• SYS_EVEN_BURST_BIT: 12.8 DPM (5%)</a:t>
+            </a:r>
+            <a:br/>
+            <a:r>
+              <a:t>• MULTI_HALFBANK_SINGLE_DQ: 8.7 DPM (3%)</a:t>
+            </a:r>
+            <a:br/>
+            <a:r>
+              <a:t>• UNKNOWN: 7.4 DPM (3%)</a:t>
+            </a:r>
+            <a:br/>
+            <a:r>
+              <a:t>• MULTI_HALFBANK_MULTI_DQ: 6.2 DPM (2%)</a:t>
             </a:r>
           </a:p>
         </p:txBody>
@@ -4272,7 +4429,7 @@
         <p:spPr>
           <a:xfrm>
             <a:off x="6217920" y="1097280"/>
-            <a:ext cx="5486400" cy="5029200"/>
+            <a:ext cx="5486400" cy="4572000"/>
           </a:xfrm>
           <a:prstGeom prst="rect">
             <a:avLst/>
@@ -4286,50 +4443,46 @@
           <a:lstStyle/>
           <a:p>
             <a:pPr>
-              <a:defRPr sz="1400"/>
+              <a:defRPr sz="1300"/>
             </a:pPr>
             <a:r>
               <a:t>QMON (Total: 191.2 DPM)</a:t>
             </a:r>
             <a:br/>
             <a:r>
-              <a:t>• MULTI_BANK_MULTI_DQ: 105.5 DPM</a:t>
-            </a:r>
-            <a:br/>
-            <a:r>
-              <a:t>• SINGLE_BURST_SINGLE_ROW: 25.3 DPM</a:t>
-            </a:r>
-            <a:br/>
-            <a:r>
-              <a:t>• HGDC: 7.6 DPM</a:t>
-            </a:r>
-            <a:br/>
-            <a:r>
-              <a:t>• SYS_EVEN_BURST_BIT: 6.9 DPM</a:t>
-            </a:r>
-            <a:br/>
-            <a:r>
-              <a:t>• ROW: 6.1 DPM</a:t>
-            </a:r>
-            <a:br/>
-            <a:r>
-              <a:t>• DB: 6.0 DPM</a:t>
-            </a:r>
-            <a:br/>
-            <a:r>
-              <a:t>• MULTI_HALFBANK_SINGLE_DQ: 5.0 DPM</a:t>
-            </a:r>
-            <a:br/>
-            <a:r>
-              <a:t>• MULTI_HALFBANK_MULTI_DQ: 4.7 DPM</a:t>
-            </a:r>
-            <a:br/>
-            <a:r>
-              <a:t>• SYS_ODD_BURST_BIT: 4.0 DPM</a:t>
-            </a:r>
-            <a:br/>
-            <a:r>
-              <a:t>• SB: 3.9 DPM</a:t>
+              <a:t>───────────────────────────────────</a:t>
+            </a:r>
+            <a:br/>
+            <a:r>
+              <a:t>• MULTI_BANK_MULTI_DQ: 105.5 DPM (55%)</a:t>
+            </a:r>
+            <a:br/>
+            <a:r>
+              <a:t>• SINGLE_BURST_SINGLE_ROW: 25.3 DPM (13%)</a:t>
+            </a:r>
+            <a:br/>
+            <a:r>
+              <a:t>• HGDC: 7.6 DPM (4%)</a:t>
+            </a:r>
+            <a:br/>
+            <a:r>
+              <a:t>• SYS_EVEN_BURST_BIT: 6.9 DPM (4%)</a:t>
+            </a:r>
+            <a:br/>
+            <a:r>
+              <a:t>• ROW: 6.1 DPM (3%)</a:t>
+            </a:r>
+            <a:br/>
+            <a:r>
+              <a:t>• DB: 6.0 DPM (3%)</a:t>
+            </a:r>
+            <a:br/>
+            <a:r>
+              <a:t>• MULTI_HALFBANK_SINGLE_DQ: 5.0 DPM (3%)</a:t>
+            </a:r>
+            <a:br/>
+            <a:r>
+              <a:t>• MULTI_HALFBANK_MULTI_DQ: 4.7 DPM (2%)</a:t>
             </a:r>
           </a:p>
         </p:txBody>
@@ -4342,7 +4495,7 @@
 </p:sld>
 </file>
 
-<file path=ppt/slides/slide5.xml><?xml version="1.0" encoding="utf-8"?>
+<file path=ppt/slides/slide6.xml><?xml version="1.0" encoding="utf-8"?>
 <p:sld xmlns:a="http://schemas.openxmlformats.org/drawingml/2006/main" xmlns:p="http://schemas.openxmlformats.org/presentationml/2006/main" xmlns:r="http://schemas.openxmlformats.org/officeDocument/2006/relationships">
   <p:cSld>
     <p:spTree>
@@ -4438,8 +4591,8 @@
         </p:nvSpPr>
         <p:spPr>
           <a:xfrm>
-            <a:off x="457200" y="1005840"/>
-            <a:ext cx="11277295" cy="5486400"/>
+            <a:off x="274320" y="914400"/>
+            <a:ext cx="11612880" cy="5669280"/>
           </a:xfrm>
           <a:prstGeom prst="rect">
             <a:avLst/>
@@ -4453,84 +4606,90 @@
           <a:lstStyle/>
           <a:p>
             <a:pPr>
-              <a:defRPr sz="1300"/>
+              <a:defRPr sz="1200">
+                <a:latin typeface="Consolas"/>
+              </a:defRPr>
             </a:pPr>
             <a:r>
-              <a:t>Recovery Type Mapping:</a:t>
-            </a:r>
-            <a:br/>
-            <a:br/>
-            <a:r>
-              <a:t>BIOS 100% Recovery (Full recovery projected):</a:t>
-            </a:r>
-            <a:br/>
-            <a:r>
-              <a:t>• MULTI_BANK_MULTI_DQ - Multi-bank failures recoverable via BIOS parameters</a:t>
-            </a:r>
-            <a:br/>
-            <a:br/>
-            <a:r>
-              <a:t>BIOS 50% Recovery (Partial recovery projected):</a:t>
-            </a:r>
-            <a:br/>
-            <a:r>
-              <a:t>• SINGLE_BURST_SINGLE_ROW, HGDC, SYS_EVEN_BURST_BIT, SYS_ODD_BURST_BIT</a:t>
-            </a:r>
-            <a:br/>
-            <a:r>
-              <a:t>• MULTI_BANK_2ROW, SECTION_FAIL_PERIPH, SECTION_TWO_ROW</a:t>
-            </a:r>
-            <a:br/>
-            <a:br/>
-            <a:r>
-              <a:t>HW+SOP 100% Recovery (Hardware/SOP fixes):</a:t>
-            </a:r>
-            <a:br/>
-            <a:r>
-              <a:t>• HANG - System hang recoverable via hardware/SOP improvements</a:t>
-            </a:r>
-            <a:br/>
-            <a:br/>
-            <a:r>
-              <a:t>RPx 0% Recovery (Verified - No false fails found):</a:t>
-            </a:r>
-            <a:br/>
-            <a:r>
-              <a:t>• MULTI_HALFBANK_SINGLE_DQ, MULTI_HALFBANK_MULTI_DQ, ROW</a:t>
-            </a:r>
-            <a:br/>
-            <a:r>
-              <a:t>• MULTI_BANK_SINGLE_DQ, ROW_LOCAL, ROW_LOCAL_SWL_ARM</a:t>
-            </a:r>
-            <a:br/>
-            <a:r>
-              <a:t>• Note: RPx script verified 0% false fail rate</a:t>
-            </a:r>
-            <a:br/>
-            <a:br/>
-            <a:r>
-              <a:t>No Recovery (True failures):</a:t>
-            </a:r>
-            <a:br/>
-            <a:r>
-              <a:t>• SB, DB, UNKNOWN, BOOT, SB_MODSYS, SINGLE_BANK</a:t>
-            </a:r>
-            <a:br/>
-            <a:r>
-              <a:t>• GLOBAL_COLUMN_SELECT, DB_SAMEROW, COL_FUSE</a:t>
-            </a:r>
-            <a:br/>
-            <a:br/>
-            <a:r>
-              <a:t>Special Note for ROW MSN_STATUS:</a:t>
-            </a:r>
-            <a:br/>
-            <a:r>
-              <a:t>• ROW failures do NOT get BIOS recovery patterns</a:t>
-            </a:r>
-            <a:br/>
-            <a:r>
-              <a:t>• Only RPx screening can recover ROW failures (verified 0%)</a:t>
+              <a:t>Recovery Mechanism Mapping:</a:t>
+            </a:r>
+            <a:br/>
+            <a:br/>
+            <a:r>
+              <a:t>┌─────────────────────────────────────────────────────────────────────────┐</a:t>
+            </a:r>
+            <a:br/>
+            <a:r>
+              <a:t>│ BIOS 100% Recovery (Full recovery projected)                            │</a:t>
+            </a:r>
+            <a:br/>
+            <a:r>
+              <a:t>│   • MULTI_BANK_MULTI_DQ - Multi-bank failures recoverable via BIOS      │</a:t>
+            </a:r>
+            <a:br/>
+            <a:r>
+              <a:t>├─────────────────────────────────────────────────────────────────────────┤</a:t>
+            </a:r>
+            <a:br/>
+            <a:r>
+              <a:t>│ BIOS 50% Recovery (Partial recovery projected)                          │</a:t>
+            </a:r>
+            <a:br/>
+            <a:r>
+              <a:t>│   • SINGLE_BURST_SINGLE_ROW, HGDC, SYS_EVEN_BURST_BIT                   │</a:t>
+            </a:r>
+            <a:br/>
+            <a:r>
+              <a:t>│   • SYS_ODD_BURST_BIT, MULTI_BANK_2ROW, SECTION_FAIL_PERIPH             │</a:t>
+            </a:r>
+            <a:br/>
+            <a:r>
+              <a:t>├─────────────────────────────────────────────────────────────────────────┤</a:t>
+            </a:r>
+            <a:br/>
+            <a:r>
+              <a:t>│ HW+SOP 100% Recovery (Hardware/SOP fixes)                               │</a:t>
+            </a:r>
+            <a:br/>
+            <a:r>
+              <a:t>│   • HANG - System hang recoverable via hardware/SOP improvements        │</a:t>
+            </a:r>
+            <a:br/>
+            <a:r>
+              <a:t>├─────────────────────────────────────────────────────────────────────────┤</a:t>
+            </a:r>
+            <a:br/>
+            <a:r>
+              <a:t>│ RPx 0% Recovery (Verified - No false fails found)                       │</a:t>
+            </a:r>
+            <a:br/>
+            <a:r>
+              <a:t>│   • MULTI_HALFBANK_*, ROW, ROW_LOCAL, MULTI_BANK_SINGLE_DQ              │</a:t>
+            </a:r>
+            <a:br/>
+            <a:r>
+              <a:t>│   • Note: socamm_false_miscompare.py verified 0% false fail rate        │</a:t>
+            </a:r>
+            <a:br/>
+            <a:r>
+              <a:t>├─────────────────────────────────────────────────────────────────────────┤</a:t>
+            </a:r>
+            <a:br/>
+            <a:r>
+              <a:t>│ No Recovery (True failures - customer-facing)                           │</a:t>
+            </a:r>
+            <a:br/>
+            <a:r>
+              <a:t>│   • SB, DB, UNKNOWN, BOOT, SB_MODSYS, SINGLE_BANK, COL_FUSE             │</a:t>
+            </a:r>
+            <a:br/>
+            <a:r>
+              <a:t>└─────────────────────────────────────────────────────────────────────────┘</a:t>
+            </a:r>
+            <a:br/>
+            <a:br/>
+            <a:r>
+              <a:t>Note: ROW MSN_STATUS does NOT get BIOS recovery - only RPx can recover ROW failures</a:t>
             </a:r>
           </a:p>
         </p:txBody>
@@ -4543,7 +4702,7 @@
 </p:sld>
 </file>
 
-<file path=ppt/slides/slide6.xml><?xml version="1.0" encoding="utf-8"?>
+<file path=ppt/slides/slide7.xml><?xml version="1.0" encoding="utf-8"?>
 <p:sld xmlns:a="http://schemas.openxmlformats.org/drawingml/2006/main" xmlns:p="http://schemas.openxmlformats.org/presentationml/2006/main" xmlns:r="http://schemas.openxmlformats.org/officeDocument/2006/relationships">
   <p:cSld>
     <p:spTree>
@@ -4640,8 +4799,8 @@
           <p:nvPr/>
         </p:nvGraphicFramePr>
         <p:xfrm>
-          <a:off x="1371600" y="1188720"/>
-          <a:ext cx="9144000" cy="2743200"/>
+          <a:off x="914400" y="1188720"/>
+          <a:ext cx="10058400" cy="2926080"/>
         </p:xfrm>
         <a:graphic>
           <a:graphicData uri="http://schemas.openxmlformats.org/drawingml/2006/table">
@@ -4650,12 +4809,13 @@
                 <a:tableStyleId>{5C22544A-7EE6-4342-B048-85BDC9FD1C3A}</a:tableStyleId>
               </a:tblPr>
               <a:tblGrid>
-                <a:gridCol w="2286000"/>
-                <a:gridCol w="2286000"/>
-                <a:gridCol w="2286000"/>
-                <a:gridCol w="2286000"/>
+                <a:gridCol w="2011680"/>
+                <a:gridCol w="2011680"/>
+                <a:gridCol w="2011680"/>
+                <a:gridCol w="2011680"/>
+                <a:gridCol w="2011680"/>
               </a:tblGrid>
-              <a:tr h="342900">
+              <a:tr h="365760">
                 <a:tc>
                   <a:txBody>
                     <a:bodyPr/>
@@ -4748,8 +4908,31 @@
                     </a:solidFill>
                   </a:tcPr>
                 </a:tc>
+                <a:tc>
+                  <a:txBody>
+                    <a:bodyPr/>
+                    <a:lstStyle/>
+                    <a:p>
+                      <a:pPr algn="ctr">
+                        <a:defRPr sz="1400" b="1">
+                          <a:solidFill>
+                            <a:srgbClr val="FFFFFF"/>
+                          </a:solidFill>
+                        </a:defRPr>
+                      </a:pPr>
+                      <a:r>
+                        <a:t>Rate</a:t>
+                      </a:r>
+                    </a:p>
+                  </a:txBody>
+                  <a:tcPr>
+                    <a:solidFill>
+                      <a:srgbClr val="003366"/>
+                    </a:solidFill>
+                  </a:tcPr>
+                </a:tc>
               </a:tr>
-              <a:tr h="342900">
+              <a:tr h="365760">
                 <a:tc>
                   <a:txBody>
                     <a:bodyPr/>
@@ -4810,8 +4993,23 @@
                   </a:txBody>
                   <a:tcPr/>
                 </a:tc>
+                <a:tc>
+                  <a:txBody>
+                    <a:bodyPr/>
+                    <a:lstStyle/>
+                    <a:p>
+                      <a:pPr algn="ctr">
+                        <a:defRPr sz="1400"/>
+                      </a:pPr>
+                      <a:r>
+                        <a:t>100%</a:t>
+                      </a:r>
+                    </a:p>
+                  </a:txBody>
+                  <a:tcPr/>
+                </a:tc>
               </a:tr>
-              <a:tr h="342900">
+              <a:tr h="365760">
                 <a:tc>
                   <a:txBody>
                     <a:bodyPr/>
@@ -4872,8 +5070,23 @@
                   </a:txBody>
                   <a:tcPr/>
                 </a:tc>
+                <a:tc>
+                  <a:txBody>
+                    <a:bodyPr/>
+                    <a:lstStyle/>
+                    <a:p>
+                      <a:pPr algn="ctr">
+                        <a:defRPr sz="1400"/>
+                      </a:pPr>
+                      <a:r>
+                        <a:t>50%</a:t>
+                      </a:r>
+                    </a:p>
+                  </a:txBody>
+                  <a:tcPr/>
+                </a:tc>
               </a:tr>
-              <a:tr h="342900">
+              <a:tr h="365760">
                 <a:tc>
                   <a:txBody>
                     <a:bodyPr/>
@@ -4934,8 +5147,23 @@
                   </a:txBody>
                   <a:tcPr/>
                 </a:tc>
+                <a:tc>
+                  <a:txBody>
+                    <a:bodyPr/>
+                    <a:lstStyle/>
+                    <a:p>
+                      <a:pPr algn="ctr">
+                        <a:defRPr sz="1400"/>
+                      </a:pPr>
+                      <a:r>
+                        <a:t>100%</a:t>
+                      </a:r>
+                    </a:p>
+                  </a:txBody>
+                  <a:tcPr/>
+                </a:tc>
               </a:tr>
-              <a:tr h="342900">
+              <a:tr h="365760">
                 <a:tc>
                   <a:txBody>
                     <a:bodyPr/>
@@ -4996,8 +5224,23 @@
                   </a:txBody>
                   <a:tcPr/>
                 </a:tc>
+                <a:tc>
+                  <a:txBody>
+                    <a:bodyPr/>
+                    <a:lstStyle/>
+                    <a:p>
+                      <a:pPr algn="ctr">
+                        <a:defRPr sz="1400"/>
+                      </a:pPr>
+                      <a:r>
+                        <a:t>0%</a:t>
+                      </a:r>
+                    </a:p>
+                  </a:txBody>
+                  <a:tcPr/>
+                </a:tc>
               </a:tr>
-              <a:tr h="342900">
+              <a:tr h="365760">
                 <a:tc>
                   <a:txBody>
                     <a:bodyPr/>
@@ -5013,7 +5256,7 @@
                   </a:txBody>
                   <a:tcPr>
                     <a:solidFill>
-                      <a:srgbClr val="DCE6F1"/>
+                      <a:srgbClr val="C6E0B4"/>
                     </a:solidFill>
                   </a:tcPr>
                 </a:tc>
@@ -5032,7 +5275,7 @@
                   </a:txBody>
                   <a:tcPr>
                     <a:solidFill>
-                      <a:srgbClr val="DCE6F1"/>
+                      <a:srgbClr val="C6E0B4"/>
                     </a:solidFill>
                   </a:tcPr>
                 </a:tc>
@@ -5051,7 +5294,7 @@
                   </a:txBody>
                   <a:tcPr>
                     <a:solidFill>
-                      <a:srgbClr val="DCE6F1"/>
+                      <a:srgbClr val="C6E0B4"/>
                     </a:solidFill>
                   </a:tcPr>
                 </a:tc>
@@ -5070,12 +5313,31 @@
                   </a:txBody>
                   <a:tcPr>
                     <a:solidFill>
-                      <a:srgbClr val="DCE6F1"/>
+                      <a:srgbClr val="C6E0B4"/>
+                    </a:solidFill>
+                  </a:tcPr>
+                </a:tc>
+                <a:tc>
+                  <a:txBody>
+                    <a:bodyPr/>
+                    <a:lstStyle/>
+                    <a:p>
+                      <a:pPr algn="ctr">
+                        <a:defRPr sz="1400" b="1"/>
+                      </a:pPr>
+                      <a:r>
+                        <a:t>-</a:t>
+                      </a:r>
+                    </a:p>
+                  </a:txBody>
+                  <a:tcPr>
+                    <a:solidFill>
+                      <a:srgbClr val="C6E0B4"/>
                     </a:solidFill>
                   </a:tcPr>
                 </a:tc>
               </a:tr>
-              <a:tr h="342900">
+              <a:tr h="365760">
                 <a:tc>
                   <a:txBody>
                     <a:bodyPr/>
@@ -5100,7 +5362,7 @@
                         <a:defRPr sz="1400"/>
                       </a:pPr>
                       <a:r>
-                        <a:t>21.1</a:t>
+                        <a:t>41.3</a:t>
                       </a:r>
                     </a:p>
                   </a:txBody>
@@ -5115,7 +5377,7 @@
                         <a:defRPr sz="1400"/>
                       </a:pPr>
                       <a:r>
-                        <a:t>15.1</a:t>
+                        <a:t>30.9</a:t>
                       </a:r>
                     </a:p>
                   </a:txBody>
@@ -5130,14 +5392,29 @@
                         <a:defRPr sz="1400"/>
                       </a:pPr>
                       <a:r>
-                        <a:t>36.2</a:t>
+                        <a:t>72.2</a:t>
+                      </a:r>
+                    </a:p>
+                  </a:txBody>
+                  <a:tcPr/>
+                </a:tc>
+                <a:tc>
+                  <a:txBody>
+                    <a:bodyPr/>
+                    <a:lstStyle/>
+                    <a:p>
+                      <a:pPr algn="ctr">
+                        <a:defRPr sz="1400"/>
+                      </a:pPr>
+                      <a:r>
+                        <a:t>0%</a:t>
                       </a:r>
                     </a:p>
                   </a:txBody>
                   <a:tcPr/>
                 </a:tc>
               </a:tr>
-              <a:tr h="342900">
+              <a:tr h="365760">
                 <a:tc>
                   <a:txBody>
                     <a:bodyPr/>
@@ -5153,7 +5430,7 @@
                   </a:txBody>
                   <a:tcPr>
                     <a:solidFill>
-                      <a:srgbClr val="DCE6F1"/>
+                      <a:srgbClr val="FFEB9C"/>
                     </a:solidFill>
                   </a:tcPr>
                 </a:tc>
@@ -5166,13 +5443,13 @@
                         <a:defRPr sz="1400" b="1"/>
                       </a:pPr>
                       <a:r>
-                        <a:t>97.7</a:t>
+                        <a:t>98.6</a:t>
                       </a:r>
                     </a:p>
                   </a:txBody>
                   <a:tcPr>
                     <a:solidFill>
-                      <a:srgbClr val="DCE6F1"/>
+                      <a:srgbClr val="FFEB9C"/>
                     </a:solidFill>
                   </a:tcPr>
                 </a:tc>
@@ -5191,7 +5468,7 @@
                   </a:txBody>
                   <a:tcPr>
                     <a:solidFill>
-                      <a:srgbClr val="DCE6F1"/>
+                      <a:srgbClr val="FFEB9C"/>
                     </a:solidFill>
                   </a:tcPr>
                 </a:tc>
@@ -5204,13 +5481,32 @@
                         <a:defRPr sz="1400" b="1"/>
                       </a:pPr>
                       <a:r>
-                        <a:t>157.1</a:t>
+                        <a:t>157.9</a:t>
                       </a:r>
                     </a:p>
                   </a:txBody>
                   <a:tcPr>
                     <a:solidFill>
-                      <a:srgbClr val="DCE6F1"/>
+                      <a:srgbClr val="FFEB9C"/>
+                    </a:solidFill>
+                  </a:tcPr>
+                </a:tc>
+                <a:tc>
+                  <a:txBody>
+                    <a:bodyPr/>
+                    <a:lstStyle/>
+                    <a:p>
+                      <a:pPr algn="ctr">
+                        <a:defRPr sz="1400" b="1"/>
+                      </a:pPr>
+                      <a:r>
+                        <a:t>-</a:t>
+                      </a:r>
+                    </a:p>
+                  </a:txBody>
+                  <a:tcPr>
+                    <a:solidFill>
+                      <a:srgbClr val="FFEB9C"/>
                     </a:solidFill>
                   </a:tcPr>
                 </a:tc>
@@ -5227,7 +5523,7 @@
 </p:sld>
 </file>
 
-<file path=ppt/slides/slide7.xml><?xml version="1.0" encoding="utf-8"?>
+<file path=ppt/slides/slide8.xml><?xml version="1.0" encoding="utf-8"?>
 <p:sld xmlns:a="http://schemas.openxmlformats.org/drawingml/2006/main" xmlns:p="http://schemas.openxmlformats.org/presentationml/2006/main" xmlns:r="http://schemas.openxmlformats.org/officeDocument/2006/relationships">
   <p:cSld>
     <p:spTree>
@@ -5323,14 +5619,14 @@
         </p:nvSpPr>
         <p:spPr>
           <a:xfrm>
-            <a:off x="914400" y="1828800"/>
-            <a:ext cx="1097280" cy="3200400"/>
+            <a:off x="731520" y="1920239"/>
+            <a:ext cx="1280160" cy="2926080"/>
           </a:xfrm>
           <a:prstGeom prst="rect">
             <a:avLst/>
           </a:prstGeom>
           <a:solidFill>
-            <a:srgbClr val="FF6666"/>
+            <a:srgbClr val="C0504D"/>
           </a:solidFill>
           <a:ln>
             <a:noFill/>
@@ -5366,8 +5662,8 @@
         </p:nvSpPr>
         <p:spPr>
           <a:xfrm>
-            <a:off x="914400" y="1554480"/>
-            <a:ext cx="1097280" cy="274320"/>
+            <a:off x="731520" y="1600199"/>
+            <a:ext cx="1280160" cy="320040"/>
           </a:xfrm>
           <a:prstGeom prst="rect">
             <a:avLst/>
@@ -5381,10 +5677,10 @@
           <a:lstStyle/>
           <a:p>
             <a:pPr algn="ctr">
-              <a:defRPr sz="1100" b="1"/>
+              <a:defRPr sz="1200" b="1"/>
             </a:pPr>
             <a:r>
-              <a:t>456.0</a:t>
+              <a:t>456.9</a:t>
             </a:r>
           </a:p>
         </p:txBody>
@@ -5397,8 +5693,8 @@
         </p:nvSpPr>
         <p:spPr>
           <a:xfrm>
-            <a:off x="822960" y="5120640"/>
-            <a:ext cx="1280160" cy="548640"/>
+            <a:off x="640080" y="4937759"/>
+            <a:ext cx="1463039" cy="640080"/>
           </a:xfrm>
           <a:prstGeom prst="rect">
             <a:avLst/>
@@ -5412,7 +5708,7 @@
           <a:lstStyle/>
           <a:p>
             <a:pPr algn="ctr">
-              <a:defRPr sz="900"/>
+              <a:defRPr sz="1000"/>
             </a:pPr>
             <a:r>
               <a:t>Total</a:t>
@@ -5432,14 +5728,14 @@
         </p:nvSpPr>
         <p:spPr>
           <a:xfrm>
-            <a:off x="2286000" y="3600951"/>
-            <a:ext cx="1097280" cy="1428248"/>
+            <a:off x="2240280" y="3543007"/>
+            <a:ext cx="1280160" cy="1303312"/>
           </a:xfrm>
           <a:prstGeom prst="rect">
             <a:avLst/>
           </a:prstGeom>
           <a:solidFill>
-            <a:srgbClr val="90EE90"/>
+            <a:srgbClr val="92D050"/>
           </a:solidFill>
           <a:ln>
             <a:noFill/>
@@ -5475,8 +5771,8 @@
         </p:nvSpPr>
         <p:spPr>
           <a:xfrm>
-            <a:off x="2286000" y="3326631"/>
-            <a:ext cx="1097280" cy="274320"/>
+            <a:off x="2240280" y="3222967"/>
+            <a:ext cx="1280160" cy="320040"/>
           </a:xfrm>
           <a:prstGeom prst="rect">
             <a:avLst/>
@@ -5490,7 +5786,7 @@
           <a:lstStyle/>
           <a:p>
             <a:pPr algn="ctr">
-              <a:defRPr sz="1100" b="1"/>
+              <a:defRPr sz="1200" b="1"/>
             </a:pPr>
             <a:r>
               <a:t>-203.5</a:t>
@@ -5506,8 +5802,8 @@
         </p:nvSpPr>
         <p:spPr>
           <a:xfrm>
-            <a:off x="2194560" y="5120640"/>
-            <a:ext cx="1280160" cy="548640"/>
+            <a:off x="2148840" y="4937759"/>
+            <a:ext cx="1463039" cy="640080"/>
           </a:xfrm>
           <a:prstGeom prst="rect">
             <a:avLst/>
@@ -5521,7 +5817,7 @@
           <a:lstStyle/>
           <a:p>
             <a:pPr algn="ctr">
-              <a:defRPr sz="900"/>
+              <a:defRPr sz="1000"/>
             </a:pPr>
             <a:r>
               <a:t>BIOS</a:t>
@@ -5541,14 +5837,14 @@
         </p:nvSpPr>
         <p:spPr>
           <a:xfrm>
-            <a:off x="3657600" y="4475797"/>
-            <a:ext cx="1097280" cy="553402"/>
+            <a:off x="3749039" y="4341326"/>
+            <a:ext cx="1280160" cy="504993"/>
           </a:xfrm>
           <a:prstGeom prst="rect">
             <a:avLst/>
           </a:prstGeom>
           <a:solidFill>
-            <a:srgbClr val="90EE90"/>
+            <a:srgbClr val="92D050"/>
           </a:solidFill>
           <a:ln>
             <a:noFill/>
@@ -5584,8 +5880,8 @@
         </p:nvSpPr>
         <p:spPr>
           <a:xfrm>
-            <a:off x="3657600" y="4201477"/>
-            <a:ext cx="1097280" cy="274320"/>
+            <a:off x="3749039" y="4021286"/>
+            <a:ext cx="1280160" cy="320040"/>
           </a:xfrm>
           <a:prstGeom prst="rect">
             <a:avLst/>
@@ -5599,7 +5895,7 @@
           <a:lstStyle/>
           <a:p>
             <a:pPr algn="ctr">
-              <a:defRPr sz="1100" b="1"/>
+              <a:defRPr sz="1200" b="1"/>
             </a:pPr>
             <a:r>
               <a:t>-78.8</a:t>
@@ -5615,8 +5911,8 @@
         </p:nvSpPr>
         <p:spPr>
           <a:xfrm>
-            <a:off x="3566160" y="5120640"/>
-            <a:ext cx="1280160" cy="548640"/>
+            <a:off x="3657599" y="4937759"/>
+            <a:ext cx="1463039" cy="640080"/>
           </a:xfrm>
           <a:prstGeom prst="rect">
             <a:avLst/>
@@ -5630,7 +5926,7 @@
           <a:lstStyle/>
           <a:p>
             <a:pPr algn="ctr">
-              <a:defRPr sz="900"/>
+              <a:defRPr sz="1000"/>
             </a:pPr>
             <a:r>
               <a:t>BIOS</a:t>
@@ -5650,14 +5946,14 @@
         </p:nvSpPr>
         <p:spPr>
           <a:xfrm>
-            <a:off x="5029200" y="4912694"/>
-            <a:ext cx="1097280" cy="116505"/>
+            <a:off x="5257800" y="4740005"/>
+            <a:ext cx="1280160" cy="106314"/>
           </a:xfrm>
           <a:prstGeom prst="rect">
             <a:avLst/>
           </a:prstGeom>
           <a:solidFill>
-            <a:srgbClr val="90EE90"/>
+            <a:srgbClr val="92D050"/>
           </a:solidFill>
           <a:ln>
             <a:noFill/>
@@ -5693,8 +5989,8 @@
         </p:nvSpPr>
         <p:spPr>
           <a:xfrm>
-            <a:off x="5029200" y="4638374"/>
-            <a:ext cx="1097280" cy="274320"/>
+            <a:off x="5257800" y="4419965"/>
+            <a:ext cx="1280160" cy="320040"/>
           </a:xfrm>
           <a:prstGeom prst="rect">
             <a:avLst/>
@@ -5708,7 +6004,7 @@
           <a:lstStyle/>
           <a:p>
             <a:pPr algn="ctr">
-              <a:defRPr sz="1100" b="1"/>
+              <a:defRPr sz="1200" b="1"/>
             </a:pPr>
             <a:r>
               <a:t>-16.6</a:t>
@@ -5724,8 +6020,8 @@
         </p:nvSpPr>
         <p:spPr>
           <a:xfrm>
-            <a:off x="4937760" y="5120640"/>
-            <a:ext cx="1280160" cy="548640"/>
+            <a:off x="5166360" y="4937759"/>
+            <a:ext cx="1463039" cy="640080"/>
           </a:xfrm>
           <a:prstGeom prst="rect">
             <a:avLst/>
@@ -5739,7 +6035,7 @@
           <a:lstStyle/>
           <a:p>
             <a:pPr algn="ctr">
-              <a:defRPr sz="900"/>
+              <a:defRPr sz="1000"/>
             </a:pPr>
             <a:r>
               <a:t>HW</a:t>
@@ -5759,14 +6055,14 @@
         </p:nvSpPr>
         <p:spPr>
           <a:xfrm>
-            <a:off x="6400800" y="5028498"/>
-            <a:ext cx="1097280" cy="701"/>
+            <a:off x="6766560" y="4754880"/>
+            <a:ext cx="1280160" cy="91440"/>
           </a:xfrm>
           <a:prstGeom prst="rect">
             <a:avLst/>
           </a:prstGeom>
           <a:solidFill>
-            <a:srgbClr val="C8C8C8"/>
+            <a:srgbClr val="BFBFBF"/>
           </a:solidFill>
           <a:ln>
             <a:noFill/>
@@ -5802,8 +6098,8 @@
         </p:nvSpPr>
         <p:spPr>
           <a:xfrm>
-            <a:off x="6400800" y="4754178"/>
-            <a:ext cx="1097280" cy="274320"/>
+            <a:off x="6766560" y="4434840"/>
+            <a:ext cx="1280160" cy="320040"/>
           </a:xfrm>
           <a:prstGeom prst="rect">
             <a:avLst/>
@@ -5817,7 +6113,7 @@
           <a:lstStyle/>
           <a:p>
             <a:pPr algn="ctr">
-              <a:defRPr sz="1100" b="1"/>
+              <a:defRPr sz="1200" b="1"/>
             </a:pPr>
             <a:r>
               <a:t>0.0</a:t>
@@ -5833,8 +6129,8 @@
         </p:nvSpPr>
         <p:spPr>
           <a:xfrm>
-            <a:off x="6309360" y="5120640"/>
-            <a:ext cx="1280160" cy="548640"/>
+            <a:off x="6675120" y="4937759"/>
+            <a:ext cx="1463039" cy="640080"/>
           </a:xfrm>
           <a:prstGeom prst="rect">
             <a:avLst/>
@@ -5848,7 +6144,7 @@
           <a:lstStyle/>
           <a:p>
             <a:pPr algn="ctr">
-              <a:defRPr sz="900"/>
+              <a:defRPr sz="1000"/>
             </a:pPr>
             <a:r>
               <a:t>RPx</a:t>
@@ -5868,14 +6164,14 @@
         </p:nvSpPr>
         <p:spPr>
           <a:xfrm>
-            <a:off x="7772400" y="3926956"/>
-            <a:ext cx="1097280" cy="1102243"/>
+            <a:off x="8275320" y="3834860"/>
+            <a:ext cx="1280160" cy="1011459"/>
           </a:xfrm>
           <a:prstGeom prst="rect">
             <a:avLst/>
           </a:prstGeom>
           <a:solidFill>
-            <a:srgbClr val="FFA500"/>
+            <a:srgbClr val="FFC000"/>
           </a:solidFill>
           <a:ln>
             <a:noFill/>
@@ -5911,8 +6207,8 @@
         </p:nvSpPr>
         <p:spPr>
           <a:xfrm>
-            <a:off x="7772400" y="3652636"/>
-            <a:ext cx="1097280" cy="274320"/>
+            <a:off x="8275320" y="3514820"/>
+            <a:ext cx="1280160" cy="320040"/>
           </a:xfrm>
           <a:prstGeom prst="rect">
             <a:avLst/>
@@ -5926,10 +6222,10 @@
           <a:lstStyle/>
           <a:p>
             <a:pPr algn="ctr">
-              <a:defRPr sz="1100" b="1"/>
+              <a:defRPr sz="1200" b="1"/>
             </a:pPr>
             <a:r>
-              <a:t>157.1</a:t>
+              <a:t>157.9</a:t>
             </a:r>
           </a:p>
         </p:txBody>
@@ -5942,8 +6238,8 @@
         </p:nvSpPr>
         <p:spPr>
           <a:xfrm>
-            <a:off x="7680960" y="5120640"/>
-            <a:ext cx="1280160" cy="548640"/>
+            <a:off x="8183880" y="4937759"/>
+            <a:ext cx="1463039" cy="640080"/>
           </a:xfrm>
           <a:prstGeom prst="rect">
             <a:avLst/>
@@ -5957,7 +6253,7 @@
           <a:lstStyle/>
           <a:p>
             <a:pPr algn="ctr">
-              <a:defRPr sz="900"/>
+              <a:defRPr sz="1000"/>
             </a:pPr>
             <a:r>
               <a:t>Customer</a:t>
@@ -5977,8 +6273,8 @@
         </p:nvSpPr>
         <p:spPr>
           <a:xfrm>
-            <a:off x="731520" y="5029200"/>
-            <a:ext cx="10058400" cy="18288"/>
+            <a:off x="548640" y="4846320"/>
+            <a:ext cx="10515600" cy="18288"/>
           </a:xfrm>
           <a:prstGeom prst="rect">
             <a:avLst/>
@@ -6009,6 +6305,37 @@
           </a:p>
         </p:txBody>
       </p:sp>
+      <p:sp>
+        <p:nvSpPr>
+          <p:cNvPr id="23" name="TextBox 22"/>
+          <p:cNvSpPr txBox="1"/>
+          <p:nvPr/>
+        </p:nvSpPr>
+        <p:spPr>
+          <a:xfrm>
+            <a:off x="3657600" y="1005840"/>
+            <a:ext cx="4572000" cy="457200"/>
+          </a:xfrm>
+          <a:prstGeom prst="rect">
+            <a:avLst/>
+          </a:prstGeom>
+          <a:noFill/>
+        </p:spPr>
+        <p:txBody>
+          <a:bodyPr wrap="none">
+            <a:spAutoFit/>
+          </a:bodyPr>
+          <a:lstStyle/>
+          <a:p>
+            <a:pPr algn="ctr">
+              <a:defRPr sz="1400" b="1"/>
+            </a:pPr>
+            <a:r>
+              <a:t>Recovery Rate: 65% (298.9 of 456.9 DPM)</a:t>
+            </a:r>
+          </a:p>
+        </p:txBody>
+      </p:sp>
     </p:spTree>
   </p:cSld>
   <p:clrMapOvr>
@@ -6017,7 +6344,7 @@
 </p:sld>
 </file>
 
-<file path=ppt/slides/slide8.xml><?xml version="1.0" encoding="utf-8"?>
+<file path=ppt/slides/slide9.xml><?xml version="1.0" encoding="utf-8"?>
 <p:sld xmlns:a="http://schemas.openxmlformats.org/drawingml/2006/main" xmlns:p="http://schemas.openxmlformats.org/presentationml/2006/main" xmlns:r="http://schemas.openxmlformats.org/officeDocument/2006/relationships">
   <p:cSld>
     <p:spTree>
@@ -6100,7 +6427,7 @@
               </a:defRPr>
             </a:pPr>
             <a:r>
-              <a:t>MFG → ENG Bridge: Yield to Customer DPM (Combined SLT)</a:t>
+              <a:t>Appendix: Data Sources &amp; Commands</a:t>
             </a:r>
           </a:p>
         </p:txBody>
@@ -6113,8 +6440,8 @@
         </p:nvSpPr>
         <p:spPr>
           <a:xfrm>
-            <a:off x="457200" y="1005840"/>
-            <a:ext cx="11277295" cy="5486400"/>
+            <a:off x="274320" y="914400"/>
+            <a:ext cx="11612880" cy="5669280"/>
           </a:xfrm>
           <a:prstGeom prst="rect">
             <a:avLst/>
@@ -6128,293 +6455,90 @@
           <a:lstStyle/>
           <a:p>
             <a:pPr>
-              <a:defRPr sz="1300">
+              <a:defRPr sz="1100">
                 <a:latin typeface="Consolas"/>
               </a:defRPr>
             </a:pPr>
             <a:r>
-              <a:t>Manufacturing (MFG) View:</a:t>
-            </a:r>
-            <a:br/>
-            <a:r>
-              <a:t>━━━━━━━━━━━━━━━━━━━━━━━━━</a:t>
-            </a:r>
-            <a:br/>
-            <a:r>
-              <a:t>• HMB1 1st Pass: 37,118 UIN → 98.71% Yield</a:t>
-            </a:r>
-            <a:br/>
-            <a:r>
-              <a:t>• QMON 1st Pass: 27,128 UIN → 98.88% Yield</a:t>
-            </a:r>
-            <a:br/>
-            <a:br/>
-            <a:r>
-              <a:t>Retest Recovery (imesh):</a:t>
-            </a:r>
-            <a:br/>
-            <a:r>
-              <a:t>━━━━━━━━━━━━━━━━━━━━━━━━━</a:t>
-            </a:r>
-            <a:br/>
-            <a:r>
-              <a:t>• HMB1 Final: 32,016 UIN → 98.63% Yield</a:t>
-            </a:r>
-            <a:br/>
-            <a:r>
-              <a:t>• QMON Final: 25,450 UIN → 98.83% Yield</a:t>
-            </a:r>
-            <a:br/>
-            <a:br/>
-            <a:r>
-              <a:t>Engineering (ENG) View - cDPM Analysis:</a:t>
-            </a:r>
-            <a:br/>
-            <a:r>
-              <a:t>━━━━━━━━━━━━━━━━━━━━━━━━━━━━━━━━━━━━</a:t>
-            </a:r>
-            <a:br/>
-            <a:r>
-              <a:t>• Combined Total cDPM: 456.0</a:t>
-            </a:r>
-            <a:br/>
-            <a:r>
-              <a:t>  └── BIOS 100% Recovery: -203.5 DPM</a:t>
-            </a:r>
-            <a:br/>
-            <a:r>
-              <a:t>  └── BIOS 50% Recovery: -78.8 DPM</a:t>
-            </a:r>
-            <a:br/>
-            <a:r>
-              <a:t>  └── HW+SOP Recovery: -16.6 DPM</a:t>
-            </a:r>
-            <a:br/>
-            <a:r>
-              <a:t>  └── RPx Recovery: -0.0 DPM (Verified 0%)</a:t>
-            </a:r>
-            <a:br/>
-            <a:r>
-              <a:t>  ════════════════════════════════</a:t>
-            </a:r>
-            <a:br/>
-            <a:r>
-              <a:t>  = Customer-Facing: 157.1 DPM</a:t>
-            </a:r>
-            <a:br/>
-            <a:br/>
-            <a:r>
-              <a:t>Bridge Summary:</a:t>
-            </a:r>
-            <a:br/>
-            <a:r>
-              <a:t>━━━━━━━━━━━━━━━</a:t>
-            </a:r>
-            <a:br/>
-            <a:r>
-              <a:t>MFG sees: ~98.8% Yield (shipping modules)</a:t>
-            </a:r>
-            <a:br/>
-            <a:r>
-              <a:t>ENG sees: 157.1 DPM risk to customer</a:t>
-            </a:r>
-          </a:p>
-        </p:txBody>
-      </p:sp>
-    </p:spTree>
-  </p:cSld>
-  <p:clrMapOvr>
-    <a:masterClrMapping/>
-  </p:clrMapOvr>
-</p:sld>
-</file>
-
-<file path=ppt/slides/slide9.xml><?xml version="1.0" encoding="utf-8"?>
-<p:sld xmlns:a="http://schemas.openxmlformats.org/drawingml/2006/main" xmlns:p="http://schemas.openxmlformats.org/presentationml/2006/main" xmlns:r="http://schemas.openxmlformats.org/officeDocument/2006/relationships">
-  <p:cSld>
-    <p:spTree>
-      <p:nvGrpSpPr>
-        <p:cNvPr id="1" name=""/>
-        <p:cNvGrpSpPr/>
-        <p:nvPr/>
-      </p:nvGrpSpPr>
-      <p:grpSpPr/>
-      <p:sp>
-        <p:nvSpPr>
-          <p:cNvPr id="2" name="Rectangle 1"/>
-          <p:cNvSpPr/>
-          <p:nvPr/>
-        </p:nvSpPr>
-        <p:spPr>
-          <a:xfrm>
-            <a:off x="0" y="0"/>
-            <a:ext cx="12191695" cy="822960"/>
-          </a:xfrm>
-          <a:prstGeom prst="rect">
-            <a:avLst/>
-          </a:prstGeom>
-          <a:solidFill>
-            <a:srgbClr val="003366"/>
-          </a:solidFill>
-          <a:ln>
-            <a:noFill/>
-          </a:ln>
-        </p:spPr>
-        <p:style>
-          <a:lnRef idx="1">
-            <a:schemeClr val="accent1"/>
-          </a:lnRef>
-          <a:fillRef idx="3">
-            <a:schemeClr val="accent1"/>
-          </a:fillRef>
-          <a:effectRef idx="2">
-            <a:schemeClr val="accent1"/>
-          </a:effectRef>
-          <a:fontRef idx="minor">
-            <a:schemeClr val="lt1"/>
-          </a:fontRef>
-        </p:style>
-        <p:txBody>
-          <a:bodyPr rtlCol="0" anchor="ctr"/>
-          <a:lstStyle/>
-          <a:p>
-            <a:pPr algn="ctr"/>
-          </a:p>
-        </p:txBody>
-      </p:sp>
-      <p:sp>
-        <p:nvSpPr>
-          <p:cNvPr id="3" name="TextBox 2"/>
-          <p:cNvSpPr txBox="1"/>
-          <p:nvPr/>
-        </p:nvSpPr>
-        <p:spPr>
-          <a:xfrm>
-            <a:off x="274320" y="182880"/>
-            <a:ext cx="11430000" cy="548640"/>
-          </a:xfrm>
-          <a:prstGeom prst="rect">
-            <a:avLst/>
-          </a:prstGeom>
-          <a:noFill/>
-        </p:spPr>
-        <p:txBody>
-          <a:bodyPr wrap="none">
-            <a:spAutoFit/>
-          </a:bodyPr>
-          <a:lstStyle/>
-          <a:p>
-            <a:pPr>
-              <a:defRPr sz="2800" b="1">
-                <a:solidFill>
-                  <a:srgbClr val="FFFFFF"/>
-                </a:solidFill>
-              </a:defRPr>
-            </a:pPr>
-            <a:r>
-              <a:t>DPM Calculation Methodology (Kevin Roos Method)</a:t>
-            </a:r>
-          </a:p>
-        </p:txBody>
-      </p:sp>
-      <p:sp>
-        <p:nvSpPr>
-          <p:cNvPr id="4" name="TextBox 3"/>
-          <p:cNvSpPr txBox="1"/>
-          <p:nvPr/>
-        </p:nvSpPr>
-        <p:spPr>
-          <a:xfrm>
-            <a:off x="457200" y="1005840"/>
-            <a:ext cx="11277295" cy="5486400"/>
-          </a:xfrm>
-          <a:prstGeom prst="rect">
-            <a:avLst/>
-          </a:prstGeom>
-          <a:noFill/>
-        </p:spPr>
-        <p:txBody>
-          <a:bodyPr wrap="square">
-            <a:spAutoFit/>
-          </a:bodyPr>
-          <a:lstStyle/>
-          <a:p>
-            <a:pPr>
-              <a:defRPr sz="1400"/>
-            </a:pPr>
-            <a:r>
-              <a:t>Formula:</a:t>
-            </a:r>
-            <a:br/>
-            <a:r>
-              <a:t>══════════</a:t>
-            </a:r>
-            <a:br/>
-            <a:r>
-              <a:t>        Unique Failing MSNs</a:t>
-            </a:r>
-            <a:br/>
-            <a:r>
-              <a:t>DPM = ─────────────────────── × 1,000,000</a:t>
-            </a:r>
-            <a:br/>
-            <a:r>
-              <a:t>          Total FID UIN</a:t>
-            </a:r>
-            <a:br/>
-            <a:br/>
-            <a:r>
-              <a:t>Key Points:</a:t>
-            </a:r>
-            <a:br/>
-            <a:r>
-              <a:t>• Numerator: Count of unique module serial numbers (MSNs) with failures</a:t>
-            </a:r>
-            <a:br/>
-            <a:r>
-              <a:t>  - Each module counted ONCE regardless of how many components failed</a:t>
-            </a:r>
-            <a:br/>
-            <a:r>
-              <a:t>• Denominator: Total FID UIN (component unit-in) from +fidag</a:t>
-            </a:r>
-            <a:br/>
-            <a:r>
-              <a:t>  - Represents total component population tested</a:t>
-            </a:r>
-            <a:br/>
-            <a:br/>
-            <a:r>
-              <a:t>Why This Method:</a:t>
-            </a:r>
-            <a:br/>
-            <a:r>
-              <a:t>• Provides component-level perspective for DRAM quality</a:t>
-            </a:r>
-            <a:br/>
-            <a:r>
-              <a:t>• Aligns with customer experience (one bad module = one return)</a:t>
-            </a:r>
-            <a:br/>
-            <a:r>
-              <a:t>• Enables meaningful comparison across different test steps</a:t>
-            </a:r>
-            <a:br/>
-            <a:br/>
-            <a:r>
-              <a:t>Verification:</a:t>
-            </a:r>
-            <a:br/>
-            <a:r>
-              <a:t>• HMB1: 500 unique failing MSNs / 1,881,631 FID UIN × 1M = 265.7 DPM</a:t>
-            </a:r>
-            <a:br/>
-            <a:r>
-              <a:t>• QMON: 292 unique failing MSNs / 1,527,576 FID UIN × 1M = 191.2 DPM</a:t>
-            </a:r>
-            <a:br/>
-            <a:r>
-              <a:t>• Values match mtsums +fm +fc output (264.8 and 191.2 DPM)</a:t>
+              <a:t>Data Collection:</a:t>
+            </a:r>
+            <a:br/>
+            <a:br/>
+            <a:r>
+              <a:t>1. Unique Failing MSNs (Numerator):</a:t>
+            </a:r>
+            <a:br/>
+            <a:r>
+              <a:t>   mtsums -dbase=y6cp -step={step} -module_form_factor=socamm2 \</a:t>
+            </a:r>
+            <a:br/>
+            <a:r>
+              <a:t>       -module_speed=7500MTPS -mfg_workweek=202608,...,202617 +stdf +msnag</a:t>
+            </a:r>
+            <a:br/>
+            <a:br/>
+            <a:r>
+              <a:t>2. Total FID UIN (Denominator):</a:t>
+            </a:r>
+            <a:br/>
+            <a:r>
+              <a:t>   mtsums -dbase=y6cp -step={step} -module_form_factor=socamm2 \</a:t>
+            </a:r>
+            <a:br/>
+            <a:r>
+              <a:t>       -module_speed=7500MTPS -mfg_workweek=202608,...,202617 +stdf +fidag</a:t>
+            </a:r>
+            <a:br/>
+            <a:br/>
+            <a:r>
+              <a:t>3. FAILCRAWLER Breakdown:</a:t>
+            </a:r>
+            <a:br/>
+            <a:r>
+              <a:t>   mtsums ... +stdf +fm +fc</a:t>
+            </a:r>
+            <a:br/>
+            <a:br/>
+            <a:r>
+              <a:t>4. MSN_STATUS × FAILCRAWLER Correlation:</a:t>
+            </a:r>
+            <a:br/>
+            <a:r>
+              <a:t>   mtsums ... +stdf +msnag -format=/msn_status,failcrawler/</a:t>
+            </a:r>
+            <a:br/>
+            <a:br/>
+            <a:r>
+              <a:t>5. RPx Verification:</a:t>
+            </a:r>
+            <a:br/>
+            <a:r>
+              <a:t>   /home/nmewes/Y6CP_FA/socamm_false_miscompare.py --sums {slash_paths}</a:t>
+            </a:r>
+            <a:br/>
+            <a:r>
+              <a:t>   Result: 0% false fail rate verified</a:t>
+            </a:r>
+            <a:br/>
+            <a:br/>
+            <a:r>
+              <a:t>Data Scope:</a:t>
+            </a:r>
+            <a:br/>
+            <a:r>
+              <a:t>• Product: SOCAMM2 7500MTPS</a:t>
+            </a:r>
+            <a:br/>
+            <a:r>
+              <a:t>• Period: WW202608-202617 (10 weeks cumulative)</a:t>
+            </a:r>
+            <a:br/>
+            <a:r>
+              <a:t>• Steps: HMB1, QMON</a:t>
+            </a:r>
+            <a:br/>
+            <a:r>
+              <a:t>• Database: y6cp</a:t>
             </a:r>
           </a:p>
         </p:txBody>

</xml_diff>

<commit_message>
fix: Update waterfall chart to proper floating-bar format
- Replaced bar chart with true waterfall (flying bricks) format
- Floating bars show recovery deductions suspended in mid-air
- Total cDPM and Customer-Facing as full bars from baseline
- Recovery bars (BIOS 100%, BIOS 50%, HW+SOP) as floating decreases
- Added connector lines between bars
- Added legend and recovery percentage annotation
- Matches Wikipedia waterfall chart standard
</commit_message>
<xml_diff>
--- a/Y6CP_cDPM_Recovery_VP_Readout_SOCAMM2_7500MT.pptx
+++ b/Y6CP_cDPM_Recovery_VP_Readout_SOCAMM2_7500MT.pptx
@@ -5541,14 +5541,14 @@
         </p:nvSpPr>
         <p:spPr>
           <a:xfrm>
-            <a:off x="0" y="0"/>
-            <a:ext cx="12191695" cy="822960"/>
+            <a:off x="868679" y="1787236"/>
+            <a:ext cx="1005840" cy="4156363"/>
           </a:xfrm>
           <a:prstGeom prst="rect">
             <a:avLst/>
           </a:prstGeom>
           <a:solidFill>
-            <a:srgbClr val="003366"/>
+            <a:srgbClr val="0070C0"/>
           </a:solidFill>
           <a:ln>
             <a:noFill/>
@@ -5584,8 +5584,8 @@
         </p:nvSpPr>
         <p:spPr>
           <a:xfrm>
-            <a:off x="274320" y="182880"/>
-            <a:ext cx="11430000" cy="548640"/>
+            <a:off x="868679" y="1467196"/>
+            <a:ext cx="1005840" cy="274320"/>
           </a:xfrm>
           <a:prstGeom prst="rect">
             <a:avLst/>
@@ -5598,35 +5598,70 @@
           </a:bodyPr>
           <a:lstStyle/>
           <a:p>
-            <a:pPr>
-              <a:defRPr sz="2800" b="1">
+            <a:pPr algn="ctr">
+              <a:defRPr sz="1100" b="1">
                 <a:solidFill>
-                  <a:srgbClr val="FFFFFF"/>
+                  <a:srgbClr val="000000"/>
                 </a:solidFill>
               </a:defRPr>
             </a:pPr>
             <a:r>
-              <a:t>DPM Waterfall: Total → Customer-Facing (Combined SLT)</a:t>
-            </a:r>
-          </a:p>
-        </p:txBody>
-      </p:sp>
-      <p:sp>
-        <p:nvSpPr>
-          <p:cNvPr id="4" name="Rectangle 3"/>
+              <a:t>456.9</a:t>
+            </a:r>
+          </a:p>
+        </p:txBody>
+      </p:sp>
+      <p:sp>
+        <p:nvSpPr>
+          <p:cNvPr id="4" name="TextBox 3"/>
+          <p:cNvSpPr txBox="1"/>
+          <p:nvPr/>
+        </p:nvSpPr>
+        <p:spPr>
+          <a:xfrm>
+            <a:off x="868679" y="6035040"/>
+            <a:ext cx="1005840" cy="457200"/>
+          </a:xfrm>
+          <a:prstGeom prst="rect">
+            <a:avLst/>
+          </a:prstGeom>
+          <a:noFill/>
+        </p:spPr>
+        <p:txBody>
+          <a:bodyPr wrap="square">
+            <a:spAutoFit/>
+          </a:bodyPr>
+          <a:lstStyle/>
+          <a:p>
+            <a:pPr algn="ctr">
+              <a:defRPr sz="1000" b="1">
+                <a:solidFill>
+                  <a:srgbClr val="000000"/>
+                </a:solidFill>
+              </a:defRPr>
+            </a:pPr>
+            <a:r>
+              <a:t>Total cDPM</a:t>
+            </a:r>
+          </a:p>
+        </p:txBody>
+      </p:sp>
+      <p:sp>
+        <p:nvSpPr>
+          <p:cNvPr id="5" name="Rectangle 4"/>
           <p:cNvSpPr/>
           <p:nvPr/>
         </p:nvSpPr>
         <p:spPr>
           <a:xfrm>
-            <a:off x="731520" y="1920239"/>
-            <a:ext cx="1280160" cy="2926080"/>
+            <a:off x="2148839" y="1787236"/>
+            <a:ext cx="1005840" cy="1851295"/>
           </a:xfrm>
           <a:prstGeom prst="rect">
             <a:avLst/>
           </a:prstGeom>
           <a:solidFill>
-            <a:srgbClr val="C0504D"/>
+            <a:srgbClr val="FF6347"/>
           </a:solidFill>
           <a:ln>
             <a:noFill/>
@@ -5656,14 +5691,14 @@
       </p:sp>
       <p:sp>
         <p:nvSpPr>
-          <p:cNvPr id="5" name="TextBox 4"/>
+          <p:cNvPr id="6" name="TextBox 5"/>
           <p:cNvSpPr txBox="1"/>
           <p:nvPr/>
         </p:nvSpPr>
         <p:spPr>
           <a:xfrm>
-            <a:off x="731520" y="1600199"/>
-            <a:ext cx="1280160" cy="320040"/>
+            <a:off x="2148839" y="2575724"/>
+            <a:ext cx="1005840" cy="274320"/>
           </a:xfrm>
           <a:prstGeom prst="rect">
             <a:avLst/>
@@ -5677,24 +5712,28 @@
           <a:lstStyle/>
           <a:p>
             <a:pPr algn="ctr">
-              <a:defRPr sz="1200" b="1"/>
+              <a:defRPr sz="1100" b="1">
+                <a:solidFill>
+                  <a:srgbClr val="000000"/>
+                </a:solidFill>
+              </a:defRPr>
             </a:pPr>
             <a:r>
-              <a:t>456.9</a:t>
-            </a:r>
-          </a:p>
-        </p:txBody>
-      </p:sp>
-      <p:sp>
-        <p:nvSpPr>
-          <p:cNvPr id="6" name="TextBox 5"/>
+              <a:t>-203.5</a:t>
+            </a:r>
+          </a:p>
+        </p:txBody>
+      </p:sp>
+      <p:sp>
+        <p:nvSpPr>
+          <p:cNvPr id="7" name="TextBox 6"/>
           <p:cNvSpPr txBox="1"/>
           <p:nvPr/>
         </p:nvSpPr>
         <p:spPr>
           <a:xfrm>
-            <a:off x="640080" y="4937759"/>
-            <a:ext cx="1463039" cy="640080"/>
+            <a:off x="2148839" y="6035040"/>
+            <a:ext cx="1005840" cy="457200"/>
           </a:xfrm>
           <a:prstGeom prst="rect">
             <a:avLst/>
@@ -5708,34 +5747,34 @@
           <a:lstStyle/>
           <a:p>
             <a:pPr algn="ctr">
-              <a:defRPr sz="1000"/>
+              <a:defRPr sz="1000" b="1">
+                <a:solidFill>
+                  <a:srgbClr val="000000"/>
+                </a:solidFill>
+              </a:defRPr>
             </a:pPr>
             <a:r>
-              <a:t>Total</a:t>
-            </a:r>
-            <a:br/>
-            <a:r>
-              <a:t>cDPM</a:t>
-            </a:r>
-          </a:p>
-        </p:txBody>
-      </p:sp>
-      <p:sp>
-        <p:nvSpPr>
-          <p:cNvPr id="7" name="Rectangle 6"/>
+              <a:t>BIOS 100%</a:t>
+            </a:r>
+          </a:p>
+        </p:txBody>
+      </p:sp>
+      <p:sp>
+        <p:nvSpPr>
+          <p:cNvPr id="8" name="Rectangle 7"/>
           <p:cNvSpPr/>
           <p:nvPr/>
         </p:nvSpPr>
         <p:spPr>
           <a:xfrm>
-            <a:off x="2240280" y="3543007"/>
-            <a:ext cx="1280160" cy="1303312"/>
+            <a:off x="3428999" y="3638532"/>
+            <a:ext cx="1005840" cy="717320"/>
           </a:xfrm>
           <a:prstGeom prst="rect">
             <a:avLst/>
           </a:prstGeom>
           <a:solidFill>
-            <a:srgbClr val="92D050"/>
+            <a:srgbClr val="FF6347"/>
           </a:solidFill>
           <a:ln>
             <a:noFill/>
@@ -5765,14 +5804,14 @@
       </p:sp>
       <p:sp>
         <p:nvSpPr>
-          <p:cNvPr id="8" name="TextBox 7"/>
+          <p:cNvPr id="9" name="TextBox 8"/>
           <p:cNvSpPr txBox="1"/>
           <p:nvPr/>
         </p:nvSpPr>
         <p:spPr>
           <a:xfrm>
-            <a:off x="2240280" y="3222967"/>
-            <a:ext cx="1280160" cy="320040"/>
+            <a:off x="3428999" y="3860032"/>
+            <a:ext cx="1005840" cy="274320"/>
           </a:xfrm>
           <a:prstGeom prst="rect">
             <a:avLst/>
@@ -5786,24 +5825,28 @@
           <a:lstStyle/>
           <a:p>
             <a:pPr algn="ctr">
-              <a:defRPr sz="1200" b="1"/>
+              <a:defRPr sz="1100" b="1">
+                <a:solidFill>
+                  <a:srgbClr val="000000"/>
+                </a:solidFill>
+              </a:defRPr>
             </a:pPr>
             <a:r>
-              <a:t>-203.5</a:t>
-            </a:r>
-          </a:p>
-        </p:txBody>
-      </p:sp>
-      <p:sp>
-        <p:nvSpPr>
-          <p:cNvPr id="9" name="TextBox 8"/>
+              <a:t>-78.8</a:t>
+            </a:r>
+          </a:p>
+        </p:txBody>
+      </p:sp>
+      <p:sp>
+        <p:nvSpPr>
+          <p:cNvPr id="10" name="TextBox 9"/>
           <p:cNvSpPr txBox="1"/>
           <p:nvPr/>
         </p:nvSpPr>
         <p:spPr>
           <a:xfrm>
-            <a:off x="2148840" y="4937759"/>
-            <a:ext cx="1463039" cy="640080"/>
+            <a:off x="3428999" y="6035040"/>
+            <a:ext cx="1005840" cy="457200"/>
           </a:xfrm>
           <a:prstGeom prst="rect">
             <a:avLst/>
@@ -5817,34 +5860,34 @@
           <a:lstStyle/>
           <a:p>
             <a:pPr algn="ctr">
-              <a:defRPr sz="1000"/>
+              <a:defRPr sz="1000" b="1">
+                <a:solidFill>
+                  <a:srgbClr val="000000"/>
+                </a:solidFill>
+              </a:defRPr>
             </a:pPr>
             <a:r>
-              <a:t>BIOS</a:t>
-            </a:r>
-            <a:br/>
-            <a:r>
-              <a:t>100%</a:t>
-            </a:r>
-          </a:p>
-        </p:txBody>
-      </p:sp>
-      <p:sp>
-        <p:nvSpPr>
-          <p:cNvPr id="10" name="Rectangle 9"/>
+              <a:t>BIOS 50%</a:t>
+            </a:r>
+          </a:p>
+        </p:txBody>
+      </p:sp>
+      <p:sp>
+        <p:nvSpPr>
+          <p:cNvPr id="11" name="Rectangle 10"/>
           <p:cNvSpPr/>
           <p:nvPr/>
         </p:nvSpPr>
         <p:spPr>
           <a:xfrm>
-            <a:off x="3749039" y="4341326"/>
-            <a:ext cx="1280160" cy="504993"/>
+            <a:off x="4709159" y="4355852"/>
+            <a:ext cx="1005840" cy="151014"/>
           </a:xfrm>
           <a:prstGeom prst="rect">
             <a:avLst/>
           </a:prstGeom>
           <a:solidFill>
-            <a:srgbClr val="92D050"/>
+            <a:srgbClr val="FF6347"/>
           </a:solidFill>
           <a:ln>
             <a:noFill/>
@@ -5874,14 +5917,14 @@
       </p:sp>
       <p:sp>
         <p:nvSpPr>
-          <p:cNvPr id="11" name="TextBox 10"/>
+          <p:cNvPr id="12" name="TextBox 11"/>
           <p:cNvSpPr txBox="1"/>
           <p:nvPr/>
         </p:nvSpPr>
         <p:spPr>
           <a:xfrm>
-            <a:off x="3749039" y="4021286"/>
-            <a:ext cx="1280160" cy="320040"/>
+            <a:off x="4709159" y="4294199"/>
+            <a:ext cx="1005840" cy="274320"/>
           </a:xfrm>
           <a:prstGeom prst="rect">
             <a:avLst/>
@@ -5895,24 +5938,28 @@
           <a:lstStyle/>
           <a:p>
             <a:pPr algn="ctr">
-              <a:defRPr sz="1200" b="1"/>
+              <a:defRPr sz="1100" b="1">
+                <a:solidFill>
+                  <a:srgbClr val="000000"/>
+                </a:solidFill>
+              </a:defRPr>
             </a:pPr>
             <a:r>
-              <a:t>-78.8</a:t>
-            </a:r>
-          </a:p>
-        </p:txBody>
-      </p:sp>
-      <p:sp>
-        <p:nvSpPr>
-          <p:cNvPr id="12" name="TextBox 11"/>
+              <a:t>-16.6</a:t>
+            </a:r>
+          </a:p>
+        </p:txBody>
+      </p:sp>
+      <p:sp>
+        <p:nvSpPr>
+          <p:cNvPr id="13" name="TextBox 12"/>
           <p:cNvSpPr txBox="1"/>
           <p:nvPr/>
         </p:nvSpPr>
         <p:spPr>
           <a:xfrm>
-            <a:off x="3657599" y="4937759"/>
-            <a:ext cx="1463039" cy="640080"/>
+            <a:off x="4709159" y="6035040"/>
+            <a:ext cx="1005840" cy="457200"/>
           </a:xfrm>
           <a:prstGeom prst="rect">
             <a:avLst/>
@@ -5926,34 +5973,34 @@
           <a:lstStyle/>
           <a:p>
             <a:pPr algn="ctr">
-              <a:defRPr sz="1000"/>
+              <a:defRPr sz="1000" b="1">
+                <a:solidFill>
+                  <a:srgbClr val="000000"/>
+                </a:solidFill>
+              </a:defRPr>
             </a:pPr>
             <a:r>
-              <a:t>BIOS</a:t>
-            </a:r>
-            <a:br/>
-            <a:r>
-              <a:t>50%</a:t>
-            </a:r>
-          </a:p>
-        </p:txBody>
-      </p:sp>
-      <p:sp>
-        <p:nvSpPr>
-          <p:cNvPr id="13" name="Rectangle 12"/>
+              <a:t>HW+SOP</a:t>
+            </a:r>
+          </a:p>
+        </p:txBody>
+      </p:sp>
+      <p:sp>
+        <p:nvSpPr>
+          <p:cNvPr id="14" name="Rectangle 13"/>
           <p:cNvSpPr/>
           <p:nvPr/>
         </p:nvSpPr>
         <p:spPr>
           <a:xfrm>
-            <a:off x="5257800" y="4740005"/>
-            <a:ext cx="1280160" cy="106314"/>
+            <a:off x="5989320" y="4506867"/>
+            <a:ext cx="1005840" cy="45720"/>
           </a:xfrm>
           <a:prstGeom prst="rect">
             <a:avLst/>
           </a:prstGeom>
           <a:solidFill>
-            <a:srgbClr val="92D050"/>
+            <a:srgbClr val="808080"/>
           </a:solidFill>
           <a:ln>
             <a:noFill/>
@@ -5983,14 +6030,14 @@
       </p:sp>
       <p:sp>
         <p:nvSpPr>
-          <p:cNvPr id="14" name="TextBox 13"/>
+          <p:cNvPr id="15" name="TextBox 14"/>
           <p:cNvSpPr txBox="1"/>
           <p:nvPr/>
         </p:nvSpPr>
         <p:spPr>
           <a:xfrm>
-            <a:off x="5257800" y="4419965"/>
-            <a:ext cx="1280160" cy="320040"/>
+            <a:off x="5989320" y="4392567"/>
+            <a:ext cx="1005840" cy="274320"/>
           </a:xfrm>
           <a:prstGeom prst="rect">
             <a:avLst/>
@@ -6004,24 +6051,28 @@
           <a:lstStyle/>
           <a:p>
             <a:pPr algn="ctr">
-              <a:defRPr sz="1200" b="1"/>
+              <a:defRPr sz="1100" b="1">
+                <a:solidFill>
+                  <a:srgbClr val="000000"/>
+                </a:solidFill>
+              </a:defRPr>
             </a:pPr>
             <a:r>
-              <a:t>-16.6</a:t>
-            </a:r>
-          </a:p>
-        </p:txBody>
-      </p:sp>
-      <p:sp>
-        <p:nvSpPr>
-          <p:cNvPr id="15" name="TextBox 14"/>
+              <a:t>0</a:t>
+            </a:r>
+          </a:p>
+        </p:txBody>
+      </p:sp>
+      <p:sp>
+        <p:nvSpPr>
+          <p:cNvPr id="16" name="TextBox 15"/>
           <p:cNvSpPr txBox="1"/>
           <p:nvPr/>
         </p:nvSpPr>
         <p:spPr>
           <a:xfrm>
-            <a:off x="5166360" y="4937759"/>
-            <a:ext cx="1463039" cy="640080"/>
+            <a:off x="5989320" y="6035040"/>
+            <a:ext cx="1005840" cy="457200"/>
           </a:xfrm>
           <a:prstGeom prst="rect">
             <a:avLst/>
@@ -6035,34 +6086,34 @@
           <a:lstStyle/>
           <a:p>
             <a:pPr algn="ctr">
-              <a:defRPr sz="1000"/>
+              <a:defRPr sz="1000" b="1">
+                <a:solidFill>
+                  <a:srgbClr val="000000"/>
+                </a:solidFill>
+              </a:defRPr>
             </a:pPr>
             <a:r>
-              <a:t>HW</a:t>
-            </a:r>
-            <a:br/>
-            <a:r>
-              <a:t>+SOP</a:t>
-            </a:r>
-          </a:p>
-        </p:txBody>
-      </p:sp>
-      <p:sp>
-        <p:nvSpPr>
-          <p:cNvPr id="16" name="Rectangle 15"/>
+              <a:t>RPx</a:t>
+            </a:r>
+          </a:p>
+        </p:txBody>
+      </p:sp>
+      <p:sp>
+        <p:nvSpPr>
+          <p:cNvPr id="17" name="Rectangle 16"/>
           <p:cNvSpPr/>
           <p:nvPr/>
         </p:nvSpPr>
         <p:spPr>
           <a:xfrm>
-            <a:off x="6766560" y="4754880"/>
-            <a:ext cx="1280160" cy="91440"/>
+            <a:off x="7269480" y="4506867"/>
+            <a:ext cx="1005840" cy="1436732"/>
           </a:xfrm>
           <a:prstGeom prst="rect">
             <a:avLst/>
           </a:prstGeom>
           <a:solidFill>
-            <a:srgbClr val="BFBFBF"/>
+            <a:srgbClr val="00B050"/>
           </a:solidFill>
           <a:ln>
             <a:noFill/>
@@ -6092,14 +6143,14 @@
       </p:sp>
       <p:sp>
         <p:nvSpPr>
-          <p:cNvPr id="17" name="TextBox 16"/>
+          <p:cNvPr id="18" name="TextBox 17"/>
           <p:cNvSpPr txBox="1"/>
           <p:nvPr/>
         </p:nvSpPr>
         <p:spPr>
           <a:xfrm>
-            <a:off x="6766560" y="4434840"/>
-            <a:ext cx="1280160" cy="320040"/>
+            <a:off x="7269480" y="4186827"/>
+            <a:ext cx="1005840" cy="274320"/>
           </a:xfrm>
           <a:prstGeom prst="rect">
             <a:avLst/>
@@ -6113,24 +6164,28 @@
           <a:lstStyle/>
           <a:p>
             <a:pPr algn="ctr">
-              <a:defRPr sz="1200" b="1"/>
+              <a:defRPr sz="1100" b="1">
+                <a:solidFill>
+                  <a:srgbClr val="000000"/>
+                </a:solidFill>
+              </a:defRPr>
             </a:pPr>
             <a:r>
-              <a:t>0.0</a:t>
-            </a:r>
-          </a:p>
-        </p:txBody>
-      </p:sp>
-      <p:sp>
-        <p:nvSpPr>
-          <p:cNvPr id="18" name="TextBox 17"/>
+              <a:t>157.9</a:t>
+            </a:r>
+          </a:p>
+        </p:txBody>
+      </p:sp>
+      <p:sp>
+        <p:nvSpPr>
+          <p:cNvPr id="19" name="TextBox 18"/>
           <p:cNvSpPr txBox="1"/>
           <p:nvPr/>
         </p:nvSpPr>
         <p:spPr>
           <a:xfrm>
-            <a:off x="6675120" y="4937759"/>
-            <a:ext cx="1463039" cy="640080"/>
+            <a:off x="7269480" y="6035040"/>
+            <a:ext cx="1005840" cy="457200"/>
           </a:xfrm>
           <a:prstGeom prst="rect">
             <a:avLst/>
@@ -6144,34 +6199,34 @@
           <a:lstStyle/>
           <a:p>
             <a:pPr algn="ctr">
-              <a:defRPr sz="1000"/>
+              <a:defRPr sz="1000" b="1">
+                <a:solidFill>
+                  <a:srgbClr val="000000"/>
+                </a:solidFill>
+              </a:defRPr>
             </a:pPr>
             <a:r>
-              <a:t>RPx</a:t>
-            </a:r>
-            <a:br/>
-            <a:r>
-              <a:t>(0%)</a:t>
-            </a:r>
-          </a:p>
-        </p:txBody>
-      </p:sp>
-      <p:sp>
-        <p:nvSpPr>
-          <p:cNvPr id="19" name="Rectangle 18"/>
+              <a:t>Customer Facing</a:t>
+            </a:r>
+          </a:p>
+        </p:txBody>
+      </p:sp>
+      <p:sp>
+        <p:nvSpPr>
+          <p:cNvPr id="20" name="Rectangle 19"/>
           <p:cNvSpPr/>
           <p:nvPr/>
         </p:nvSpPr>
         <p:spPr>
           <a:xfrm>
-            <a:off x="8275320" y="3834860"/>
-            <a:ext cx="1280160" cy="1011459"/>
+            <a:off x="3154679" y="3638532"/>
+            <a:ext cx="274320" cy="18288"/>
           </a:xfrm>
           <a:prstGeom prst="rect">
             <a:avLst/>
           </a:prstGeom>
           <a:solidFill>
-            <a:srgbClr val="FFC000"/>
+            <a:srgbClr val="808080"/>
           </a:solidFill>
           <a:ln>
             <a:noFill/>
@@ -6201,87 +6256,24 @@
       </p:sp>
       <p:sp>
         <p:nvSpPr>
-          <p:cNvPr id="20" name="TextBox 19"/>
-          <p:cNvSpPr txBox="1"/>
-          <p:nvPr/>
-        </p:nvSpPr>
-        <p:spPr>
-          <a:xfrm>
-            <a:off x="8275320" y="3514820"/>
-            <a:ext cx="1280160" cy="320040"/>
-          </a:xfrm>
-          <a:prstGeom prst="rect">
-            <a:avLst/>
-          </a:prstGeom>
-          <a:noFill/>
-        </p:spPr>
-        <p:txBody>
-          <a:bodyPr wrap="none">
-            <a:spAutoFit/>
-          </a:bodyPr>
-          <a:lstStyle/>
-          <a:p>
-            <a:pPr algn="ctr">
-              <a:defRPr sz="1200" b="1"/>
-            </a:pPr>
-            <a:r>
-              <a:t>157.9</a:t>
-            </a:r>
-          </a:p>
-        </p:txBody>
-      </p:sp>
-      <p:sp>
-        <p:nvSpPr>
-          <p:cNvPr id="21" name="TextBox 20"/>
-          <p:cNvSpPr txBox="1"/>
-          <p:nvPr/>
-        </p:nvSpPr>
-        <p:spPr>
-          <a:xfrm>
-            <a:off x="8183880" y="4937759"/>
-            <a:ext cx="1463039" cy="640080"/>
-          </a:xfrm>
-          <a:prstGeom prst="rect">
-            <a:avLst/>
-          </a:prstGeom>
-          <a:noFill/>
-        </p:spPr>
-        <p:txBody>
-          <a:bodyPr wrap="square">
-            <a:spAutoFit/>
-          </a:bodyPr>
-          <a:lstStyle/>
-          <a:p>
-            <a:pPr algn="ctr">
-              <a:defRPr sz="1000"/>
-            </a:pPr>
-            <a:r>
-              <a:t>Customer</a:t>
-            </a:r>
-            <a:br/>
-            <a:r>
-              <a:t>Facing</a:t>
-            </a:r>
-          </a:p>
-        </p:txBody>
-      </p:sp>
-      <p:sp>
-        <p:nvSpPr>
-          <p:cNvPr id="22" name="Rectangle 21"/>
+          <p:cNvPr id="21" name="Rectangle 20"/>
           <p:cNvSpPr/>
           <p:nvPr/>
         </p:nvSpPr>
         <p:spPr>
           <a:xfrm>
-            <a:off x="548640" y="4846320"/>
-            <a:ext cx="10515600" cy="18288"/>
+            <a:off x="4434840" y="4355852"/>
+            <a:ext cx="274320" cy="18288"/>
           </a:xfrm>
           <a:prstGeom prst="rect">
             <a:avLst/>
           </a:prstGeom>
           <a:solidFill>
-            <a:srgbClr val="000000"/>
+            <a:srgbClr val="808080"/>
           </a:solidFill>
+          <a:ln>
+            <a:noFill/>
+          </a:ln>
         </p:spPr>
         <p:style>
           <a:lnRef idx="1">
@@ -6307,14 +6299,100 @@
       </p:sp>
       <p:sp>
         <p:nvSpPr>
-          <p:cNvPr id="23" name="TextBox 22"/>
+          <p:cNvPr id="22" name="Rectangle 21"/>
+          <p:cNvSpPr/>
+          <p:nvPr/>
+        </p:nvSpPr>
+        <p:spPr>
+          <a:xfrm>
+            <a:off x="5715000" y="4506867"/>
+            <a:ext cx="274320" cy="18288"/>
+          </a:xfrm>
+          <a:prstGeom prst="rect">
+            <a:avLst/>
+          </a:prstGeom>
+          <a:solidFill>
+            <a:srgbClr val="808080"/>
+          </a:solidFill>
+          <a:ln>
+            <a:noFill/>
+          </a:ln>
+        </p:spPr>
+        <p:style>
+          <a:lnRef idx="1">
+            <a:schemeClr val="accent1"/>
+          </a:lnRef>
+          <a:fillRef idx="3">
+            <a:schemeClr val="accent1"/>
+          </a:fillRef>
+          <a:effectRef idx="2">
+            <a:schemeClr val="accent1"/>
+          </a:effectRef>
+          <a:fontRef idx="minor">
+            <a:schemeClr val="lt1"/>
+          </a:fontRef>
+        </p:style>
+        <p:txBody>
+          <a:bodyPr rtlCol="0" anchor="ctr"/>
+          <a:lstStyle/>
+          <a:p>
+            <a:pPr algn="ctr"/>
+          </a:p>
+        </p:txBody>
+      </p:sp>
+      <p:sp>
+        <p:nvSpPr>
+          <p:cNvPr id="23" name="Rectangle 22"/>
+          <p:cNvSpPr/>
+          <p:nvPr/>
+        </p:nvSpPr>
+        <p:spPr>
+          <a:xfrm>
+            <a:off x="6858000" y="1463040"/>
+            <a:ext cx="228600" cy="182880"/>
+          </a:xfrm>
+          <a:prstGeom prst="rect">
+            <a:avLst/>
+          </a:prstGeom>
+          <a:solidFill>
+            <a:srgbClr val="0070C0"/>
+          </a:solidFill>
+          <a:ln>
+            <a:noFill/>
+          </a:ln>
+        </p:spPr>
+        <p:style>
+          <a:lnRef idx="1">
+            <a:schemeClr val="accent1"/>
+          </a:lnRef>
+          <a:fillRef idx="3">
+            <a:schemeClr val="accent1"/>
+          </a:fillRef>
+          <a:effectRef idx="2">
+            <a:schemeClr val="accent1"/>
+          </a:effectRef>
+          <a:fontRef idx="minor">
+            <a:schemeClr val="lt1"/>
+          </a:fontRef>
+        </p:style>
+        <p:txBody>
+          <a:bodyPr rtlCol="0" anchor="ctr"/>
+          <a:lstStyle/>
+          <a:p>
+            <a:pPr algn="ctr"/>
+          </a:p>
+        </p:txBody>
+      </p:sp>
+      <p:sp>
+        <p:nvSpPr>
+          <p:cNvPr id="24" name="TextBox 23"/>
           <p:cNvSpPr txBox="1"/>
           <p:nvPr/>
         </p:nvSpPr>
         <p:spPr>
           <a:xfrm>
-            <a:off x="3657600" y="1005840"/>
-            <a:ext cx="4572000" cy="457200"/>
+            <a:off x="7178040" y="1444752"/>
+            <a:ext cx="1645920" cy="228600"/>
           </a:xfrm>
           <a:prstGeom prst="rect">
             <a:avLst/>
@@ -6327,11 +6405,206 @@
           </a:bodyPr>
           <a:lstStyle/>
           <a:p>
+            <a:pPr>
+              <a:defRPr sz="900">
+                <a:solidFill>
+                  <a:srgbClr val="000000"/>
+                </a:solidFill>
+              </a:defRPr>
+            </a:pPr>
+            <a:r>
+              <a:t>Total cDPM</a:t>
+            </a:r>
+          </a:p>
+        </p:txBody>
+      </p:sp>
+      <p:sp>
+        <p:nvSpPr>
+          <p:cNvPr id="25" name="Rectangle 24"/>
+          <p:cNvSpPr/>
+          <p:nvPr/>
+        </p:nvSpPr>
+        <p:spPr>
+          <a:xfrm>
+            <a:off x="6858000" y="1783080"/>
+            <a:ext cx="228600" cy="182880"/>
+          </a:xfrm>
+          <a:prstGeom prst="rect">
+            <a:avLst/>
+          </a:prstGeom>
+          <a:solidFill>
+            <a:srgbClr val="FF6347"/>
+          </a:solidFill>
+          <a:ln>
+            <a:noFill/>
+          </a:ln>
+        </p:spPr>
+        <p:style>
+          <a:lnRef idx="1">
+            <a:schemeClr val="accent1"/>
+          </a:lnRef>
+          <a:fillRef idx="3">
+            <a:schemeClr val="accent1"/>
+          </a:fillRef>
+          <a:effectRef idx="2">
+            <a:schemeClr val="accent1"/>
+          </a:effectRef>
+          <a:fontRef idx="minor">
+            <a:schemeClr val="lt1"/>
+          </a:fontRef>
+        </p:style>
+        <p:txBody>
+          <a:bodyPr rtlCol="0" anchor="ctr"/>
+          <a:lstStyle/>
+          <a:p>
+            <a:pPr algn="ctr"/>
+          </a:p>
+        </p:txBody>
+      </p:sp>
+      <p:sp>
+        <p:nvSpPr>
+          <p:cNvPr id="26" name="TextBox 25"/>
+          <p:cNvSpPr txBox="1"/>
+          <p:nvPr/>
+        </p:nvSpPr>
+        <p:spPr>
+          <a:xfrm>
+            <a:off x="7178040" y="1764792"/>
+            <a:ext cx="1645920" cy="228600"/>
+          </a:xfrm>
+          <a:prstGeom prst="rect">
+            <a:avLst/>
+          </a:prstGeom>
+          <a:noFill/>
+        </p:spPr>
+        <p:txBody>
+          <a:bodyPr wrap="none">
+            <a:spAutoFit/>
+          </a:bodyPr>
+          <a:lstStyle/>
+          <a:p>
+            <a:pPr>
+              <a:defRPr sz="900">
+                <a:solidFill>
+                  <a:srgbClr val="000000"/>
+                </a:solidFill>
+              </a:defRPr>
+            </a:pPr>
+            <a:r>
+              <a:t>Recovery (Decrease)</a:t>
+            </a:r>
+          </a:p>
+        </p:txBody>
+      </p:sp>
+      <p:sp>
+        <p:nvSpPr>
+          <p:cNvPr id="27" name="Rectangle 26"/>
+          <p:cNvSpPr/>
+          <p:nvPr/>
+        </p:nvSpPr>
+        <p:spPr>
+          <a:xfrm>
+            <a:off x="6858000" y="2103120"/>
+            <a:ext cx="228600" cy="182880"/>
+          </a:xfrm>
+          <a:prstGeom prst="rect">
+            <a:avLst/>
+          </a:prstGeom>
+          <a:solidFill>
+            <a:srgbClr val="00B050"/>
+          </a:solidFill>
+          <a:ln>
+            <a:noFill/>
+          </a:ln>
+        </p:spPr>
+        <p:style>
+          <a:lnRef idx="1">
+            <a:schemeClr val="accent1"/>
+          </a:lnRef>
+          <a:fillRef idx="3">
+            <a:schemeClr val="accent1"/>
+          </a:fillRef>
+          <a:effectRef idx="2">
+            <a:schemeClr val="accent1"/>
+          </a:effectRef>
+          <a:fontRef idx="minor">
+            <a:schemeClr val="lt1"/>
+          </a:fontRef>
+        </p:style>
+        <p:txBody>
+          <a:bodyPr rtlCol="0" anchor="ctr"/>
+          <a:lstStyle/>
+          <a:p>
+            <a:pPr algn="ctr"/>
+          </a:p>
+        </p:txBody>
+      </p:sp>
+      <p:sp>
+        <p:nvSpPr>
+          <p:cNvPr id="28" name="TextBox 27"/>
+          <p:cNvSpPr txBox="1"/>
+          <p:nvPr/>
+        </p:nvSpPr>
+        <p:spPr>
+          <a:xfrm>
+            <a:off x="7178040" y="2084831"/>
+            <a:ext cx="1645920" cy="228600"/>
+          </a:xfrm>
+          <a:prstGeom prst="rect">
+            <a:avLst/>
+          </a:prstGeom>
+          <a:noFill/>
+        </p:spPr>
+        <p:txBody>
+          <a:bodyPr wrap="none">
+            <a:spAutoFit/>
+          </a:bodyPr>
+          <a:lstStyle/>
+          <a:p>
+            <a:pPr>
+              <a:defRPr sz="900">
+                <a:solidFill>
+                  <a:srgbClr val="000000"/>
+                </a:solidFill>
+              </a:defRPr>
+            </a:pPr>
+            <a:r>
+              <a:t>Customer-Facing</a:t>
+            </a:r>
+          </a:p>
+        </p:txBody>
+      </p:sp>
+      <p:sp>
+        <p:nvSpPr>
+          <p:cNvPr id="29" name="TextBox 28"/>
+          <p:cNvSpPr txBox="1"/>
+          <p:nvPr/>
+        </p:nvSpPr>
+        <p:spPr>
+          <a:xfrm>
+            <a:off x="457200" y="6126480"/>
+            <a:ext cx="8229600" cy="365760"/>
+          </a:xfrm>
+          <a:prstGeom prst="rect">
+            <a:avLst/>
+          </a:prstGeom>
+          <a:noFill/>
+        </p:spPr>
+        <p:txBody>
+          <a:bodyPr wrap="none">
+            <a:spAutoFit/>
+          </a:bodyPr>
+          <a:lstStyle/>
+          <a:p>
             <a:pPr algn="ctr">
-              <a:defRPr sz="1400" b="1"/>
+              <a:defRPr sz="1200" b="1">
+                <a:solidFill>
+                  <a:srgbClr val="0070C0"/>
+                </a:solidFill>
+              </a:defRPr>
             </a:pPr>
             <a:r>
-              <a:t>Recovery Rate: 65% (298.9 of 456.9 DPM)</a:t>
+              <a:t>Total Recovery: 65.4% (298.9 DPM recovered)</a:t>
             </a:r>
           </a:p>
         </p:txBody>

</xml_diff>